<commit_message>
feat(video): sezione 'Da tenere a mente' con tre accortezze trasversali
Co-Authored-By: Claude Fable 5 <noreply@anthropic.com>
</commit_message>
<xml_diff>
--- a/video/slide-video-ai.pptx
+++ b/video/slide-video-ai.pptx
@@ -27,9 +27,13 @@
     <p:sldId id="275" r:id="rId21"/>
     <p:sldId id="276" r:id="rId22"/>
     <p:sldId id="277" r:id="rId23"/>
+    <p:sldId id="278" r:id="rId24"/>
+    <p:sldId id="279" r:id="rId25"/>
+    <p:sldId id="280" r:id="rId26"/>
+    <p:sldId id="281" r:id="rId27"/>
   </p:sldIdLst>
   <p:notesMasterIdLst>
-    <p:notesMasterId r:id="rId24"/>
+    <p:notesMasterId r:id="rId28"/>
   </p:notesMasterIdLst>
   <p:sldSz cx="9144000" cy="5143500"/>
   <p:notesSz cx="5143500" cy="9144000"/>
@@ -1779,6 +1783,358 @@
             <a:fld id="{F7021451-1387-4CA6-816F-3879F97B5CBC}" type="slidenum">
               <a:rPr lang="en-US"/>
               <a:t>22</a:t>
+            </a:fld>
+            <a:endParaRPr lang="en-US"/>
+          </a:p>
+        </p:txBody>
+      </p:sp>
+    </p:spTree>
+    <p:extLst>
+      <p:ext uri="{BB962C8B-B14F-4D97-AF65-F5344CB8AC3E}">
+        <p14:creationId xmlns:p14="http://schemas.microsoft.com/office/powerpoint/2010/main" val="1024086991"/>
+      </p:ext>
+    </p:extLst>
+  </p:cSld>
+  <p:clrMapOvr>
+    <a:masterClrMapping/>
+  </p:clrMapOvr>
+</p:notes>
+</file>
+
+<file path=ppt/notesSlides/notesSlide23.xml><?xml version="1.0" encoding="utf-8"?>
+<p:notes xmlns:a="http://schemas.openxmlformats.org/drawingml/2006/main" xmlns:r="http://schemas.openxmlformats.org/officeDocument/2006/relationships" xmlns:p="http://schemas.openxmlformats.org/presentationml/2006/main">
+  <p:cSld>
+    <p:spTree>
+      <p:nvGrpSpPr>
+        <p:cNvPr id="1" name=""/>
+        <p:cNvGrpSpPr/>
+        <p:nvPr/>
+      </p:nvGrpSpPr>
+      <p:grpSpPr>
+        <a:xfrm>
+          <a:off x="0" y="0"/>
+          <a:ext cx="0" cy="0"/>
+          <a:chOff x="0" y="0"/>
+          <a:chExt cx="0" cy="0"/>
+        </a:xfrm>
+      </p:grpSpPr>
+      <p:sp>
+        <p:nvSpPr>
+          <p:cNvPr id="2" name="Slide Image Placeholder 1"/>
+          <p:cNvSpPr>
+            <a:spLocks noGrp="1" noRot="1" noChangeAspect="1"/>
+          </p:cNvSpPr>
+          <p:nvPr>
+            <p:ph type="sldImg"/>
+          </p:nvPr>
+        </p:nvSpPr>
+        <p:spPr/>
+      </p:sp>
+      <p:sp>
+        <p:nvSpPr>
+          <p:cNvPr id="3" name="Notes Placeholder 2"/>
+          <p:cNvSpPr>
+            <a:spLocks noGrp="1"/>
+          </p:cNvSpPr>
+          <p:nvPr>
+            <p:ph type="body" idx="1"/>
+          </p:nvPr>
+        </p:nvSpPr>
+        <p:spPr/>
+        <p:txBody>
+          <a:bodyPr/>
+          <a:lstStyle/>
+          <a:p>
+            <a:r>
+              <a:rPr lang="en-US" dirty="0"/>
+              <a:t/>
+            </a:r>
+            <a:endParaRPr lang="en-US" dirty="0"/>
+          </a:p>
+        </p:txBody>
+      </p:sp>
+      <p:sp>
+        <p:nvSpPr>
+          <p:cNvPr id="4" name="Slide Number Placeholder 3"/>
+          <p:cNvSpPr>
+            <a:spLocks noGrp="1"/>
+          </p:cNvSpPr>
+          <p:nvPr>
+            <p:ph type="sldNum" sz="quarter" idx="10"/>
+          </p:nvPr>
+        </p:nvSpPr>
+        <p:spPr/>
+        <p:txBody>
+          <a:bodyPr/>
+          <a:lstStyle/>
+          <a:p>
+            <a:fld id="{F7021451-1387-4CA6-816F-3879F97B5CBC}" type="slidenum">
+              <a:rPr lang="en-US"/>
+              <a:t>23</a:t>
+            </a:fld>
+            <a:endParaRPr lang="en-US"/>
+          </a:p>
+        </p:txBody>
+      </p:sp>
+    </p:spTree>
+    <p:extLst>
+      <p:ext uri="{BB962C8B-B14F-4D97-AF65-F5344CB8AC3E}">
+        <p14:creationId xmlns:p14="http://schemas.microsoft.com/office/powerpoint/2010/main" val="1024086991"/>
+      </p:ext>
+    </p:extLst>
+  </p:cSld>
+  <p:clrMapOvr>
+    <a:masterClrMapping/>
+  </p:clrMapOvr>
+</p:notes>
+</file>
+
+<file path=ppt/notesSlides/notesSlide24.xml><?xml version="1.0" encoding="utf-8"?>
+<p:notes xmlns:a="http://schemas.openxmlformats.org/drawingml/2006/main" xmlns:r="http://schemas.openxmlformats.org/officeDocument/2006/relationships" xmlns:p="http://schemas.openxmlformats.org/presentationml/2006/main">
+  <p:cSld>
+    <p:spTree>
+      <p:nvGrpSpPr>
+        <p:cNvPr id="1" name=""/>
+        <p:cNvGrpSpPr/>
+        <p:nvPr/>
+      </p:nvGrpSpPr>
+      <p:grpSpPr>
+        <a:xfrm>
+          <a:off x="0" y="0"/>
+          <a:ext cx="0" cy="0"/>
+          <a:chOff x="0" y="0"/>
+          <a:chExt cx="0" cy="0"/>
+        </a:xfrm>
+      </p:grpSpPr>
+      <p:sp>
+        <p:nvSpPr>
+          <p:cNvPr id="2" name="Slide Image Placeholder 1"/>
+          <p:cNvSpPr>
+            <a:spLocks noGrp="1" noRot="1" noChangeAspect="1"/>
+          </p:cNvSpPr>
+          <p:nvPr>
+            <p:ph type="sldImg"/>
+          </p:nvPr>
+        </p:nvSpPr>
+        <p:spPr/>
+      </p:sp>
+      <p:sp>
+        <p:nvSpPr>
+          <p:cNvPr id="3" name="Notes Placeholder 2"/>
+          <p:cNvSpPr>
+            <a:spLocks noGrp="1"/>
+          </p:cNvSpPr>
+          <p:nvPr>
+            <p:ph type="body" idx="1"/>
+          </p:nvPr>
+        </p:nvSpPr>
+        <p:spPr/>
+        <p:txBody>
+          <a:bodyPr/>
+          <a:lstStyle/>
+          <a:p>
+            <a:r>
+              <a:rPr lang="en-US" dirty="0"/>
+              <a:t/>
+            </a:r>
+            <a:endParaRPr lang="en-US" dirty="0"/>
+          </a:p>
+        </p:txBody>
+      </p:sp>
+      <p:sp>
+        <p:nvSpPr>
+          <p:cNvPr id="4" name="Slide Number Placeholder 3"/>
+          <p:cNvSpPr>
+            <a:spLocks noGrp="1"/>
+          </p:cNvSpPr>
+          <p:nvPr>
+            <p:ph type="sldNum" sz="quarter" idx="10"/>
+          </p:nvPr>
+        </p:nvSpPr>
+        <p:spPr/>
+        <p:txBody>
+          <a:bodyPr/>
+          <a:lstStyle/>
+          <a:p>
+            <a:fld id="{F7021451-1387-4CA6-816F-3879F97B5CBC}" type="slidenum">
+              <a:rPr lang="en-US"/>
+              <a:t>24</a:t>
+            </a:fld>
+            <a:endParaRPr lang="en-US"/>
+          </a:p>
+        </p:txBody>
+      </p:sp>
+    </p:spTree>
+    <p:extLst>
+      <p:ext uri="{BB962C8B-B14F-4D97-AF65-F5344CB8AC3E}">
+        <p14:creationId xmlns:p14="http://schemas.microsoft.com/office/powerpoint/2010/main" val="1024086991"/>
+      </p:ext>
+    </p:extLst>
+  </p:cSld>
+  <p:clrMapOvr>
+    <a:masterClrMapping/>
+  </p:clrMapOvr>
+</p:notes>
+</file>
+
+<file path=ppt/notesSlides/notesSlide25.xml><?xml version="1.0" encoding="utf-8"?>
+<p:notes xmlns:a="http://schemas.openxmlformats.org/drawingml/2006/main" xmlns:r="http://schemas.openxmlformats.org/officeDocument/2006/relationships" xmlns:p="http://schemas.openxmlformats.org/presentationml/2006/main">
+  <p:cSld>
+    <p:spTree>
+      <p:nvGrpSpPr>
+        <p:cNvPr id="1" name=""/>
+        <p:cNvGrpSpPr/>
+        <p:nvPr/>
+      </p:nvGrpSpPr>
+      <p:grpSpPr>
+        <a:xfrm>
+          <a:off x="0" y="0"/>
+          <a:ext cx="0" cy="0"/>
+          <a:chOff x="0" y="0"/>
+          <a:chExt cx="0" cy="0"/>
+        </a:xfrm>
+      </p:grpSpPr>
+      <p:sp>
+        <p:nvSpPr>
+          <p:cNvPr id="2" name="Slide Image Placeholder 1"/>
+          <p:cNvSpPr>
+            <a:spLocks noGrp="1" noRot="1" noChangeAspect="1"/>
+          </p:cNvSpPr>
+          <p:nvPr>
+            <p:ph type="sldImg"/>
+          </p:nvPr>
+        </p:nvSpPr>
+        <p:spPr/>
+      </p:sp>
+      <p:sp>
+        <p:nvSpPr>
+          <p:cNvPr id="3" name="Notes Placeholder 2"/>
+          <p:cNvSpPr>
+            <a:spLocks noGrp="1"/>
+          </p:cNvSpPr>
+          <p:nvPr>
+            <p:ph type="body" idx="1"/>
+          </p:nvPr>
+        </p:nvSpPr>
+        <p:spPr/>
+        <p:txBody>
+          <a:bodyPr/>
+          <a:lstStyle/>
+          <a:p>
+            <a:r>
+              <a:rPr lang="en-US" dirty="0"/>
+              <a:t/>
+            </a:r>
+            <a:endParaRPr lang="en-US" dirty="0"/>
+          </a:p>
+        </p:txBody>
+      </p:sp>
+      <p:sp>
+        <p:nvSpPr>
+          <p:cNvPr id="4" name="Slide Number Placeholder 3"/>
+          <p:cNvSpPr>
+            <a:spLocks noGrp="1"/>
+          </p:cNvSpPr>
+          <p:nvPr>
+            <p:ph type="sldNum" sz="quarter" idx="10"/>
+          </p:nvPr>
+        </p:nvSpPr>
+        <p:spPr/>
+        <p:txBody>
+          <a:bodyPr/>
+          <a:lstStyle/>
+          <a:p>
+            <a:fld id="{F7021451-1387-4CA6-816F-3879F97B5CBC}" type="slidenum">
+              <a:rPr lang="en-US"/>
+              <a:t>25</a:t>
+            </a:fld>
+            <a:endParaRPr lang="en-US"/>
+          </a:p>
+        </p:txBody>
+      </p:sp>
+    </p:spTree>
+    <p:extLst>
+      <p:ext uri="{BB962C8B-B14F-4D97-AF65-F5344CB8AC3E}">
+        <p14:creationId xmlns:p14="http://schemas.microsoft.com/office/powerpoint/2010/main" val="1024086991"/>
+      </p:ext>
+    </p:extLst>
+  </p:cSld>
+  <p:clrMapOvr>
+    <a:masterClrMapping/>
+  </p:clrMapOvr>
+</p:notes>
+</file>
+
+<file path=ppt/notesSlides/notesSlide26.xml><?xml version="1.0" encoding="utf-8"?>
+<p:notes xmlns:a="http://schemas.openxmlformats.org/drawingml/2006/main" xmlns:r="http://schemas.openxmlformats.org/officeDocument/2006/relationships" xmlns:p="http://schemas.openxmlformats.org/presentationml/2006/main">
+  <p:cSld>
+    <p:spTree>
+      <p:nvGrpSpPr>
+        <p:cNvPr id="1" name=""/>
+        <p:cNvGrpSpPr/>
+        <p:nvPr/>
+      </p:nvGrpSpPr>
+      <p:grpSpPr>
+        <a:xfrm>
+          <a:off x="0" y="0"/>
+          <a:ext cx="0" cy="0"/>
+          <a:chOff x="0" y="0"/>
+          <a:chExt cx="0" cy="0"/>
+        </a:xfrm>
+      </p:grpSpPr>
+      <p:sp>
+        <p:nvSpPr>
+          <p:cNvPr id="2" name="Slide Image Placeholder 1"/>
+          <p:cNvSpPr>
+            <a:spLocks noGrp="1" noRot="1" noChangeAspect="1"/>
+          </p:cNvSpPr>
+          <p:nvPr>
+            <p:ph type="sldImg"/>
+          </p:nvPr>
+        </p:nvSpPr>
+        <p:spPr/>
+      </p:sp>
+      <p:sp>
+        <p:nvSpPr>
+          <p:cNvPr id="3" name="Notes Placeholder 2"/>
+          <p:cNvSpPr>
+            <a:spLocks noGrp="1"/>
+          </p:cNvSpPr>
+          <p:nvPr>
+            <p:ph type="body" idx="1"/>
+          </p:nvPr>
+        </p:nvSpPr>
+        <p:spPr/>
+        <p:txBody>
+          <a:bodyPr/>
+          <a:lstStyle/>
+          <a:p>
+            <a:r>
+              <a:rPr lang="en-US" dirty="0"/>
+              <a:t/>
+            </a:r>
+            <a:endParaRPr lang="en-US" dirty="0"/>
+          </a:p>
+        </p:txBody>
+      </p:sp>
+      <p:sp>
+        <p:nvSpPr>
+          <p:cNvPr id="4" name="Slide Number Placeholder 3"/>
+          <p:cNvSpPr>
+            <a:spLocks noGrp="1"/>
+          </p:cNvSpPr>
+          <p:nvPr>
+            <p:ph type="sldNum" sz="quarter" idx="10"/>
+          </p:nvPr>
+        </p:nvSpPr>
+        <p:spPr/>
+        <p:txBody>
+          <a:bodyPr/>
+          <a:lstStyle/>
+          <a:p>
+            <a:fld id="{F7021451-1387-4CA6-816F-3879F97B5CBC}" type="slidenum">
+              <a:rPr lang="en-US"/>
+              <a:t>26</a:t>
             </a:fld>
             <a:endParaRPr lang="en-US"/>
           </a:p>
@@ -11708,6 +12064,2241 @@
 </p:sld>
 </file>
 
+<file path=ppt/slides/slide23.xml><?xml version="1.0" encoding="utf-8"?>
+<p:sld xmlns:a="http://schemas.openxmlformats.org/drawingml/2006/main" xmlns:r="http://schemas.openxmlformats.org/officeDocument/2006/relationships" xmlns:p="http://schemas.openxmlformats.org/presentationml/2006/main">
+  <p:cSld name="Slide 23">
+    <p:bg>
+      <p:bgPr>
+        <a:solidFill>
+          <a:srgbClr val="0B1226"/>
+        </a:solidFill>
+      </p:bgPr>
+    </p:bg>
+    <p:spTree>
+      <p:nvGrpSpPr>
+        <p:cNvPr id="1" name=""/>
+        <p:cNvGrpSpPr/>
+        <p:nvPr/>
+      </p:nvGrpSpPr>
+      <p:grpSpPr>
+        <a:xfrm>
+          <a:off x="0" y="0"/>
+          <a:ext cx="0" cy="0"/>
+          <a:chOff x="0" y="0"/>
+          <a:chExt cx="0" cy="0"/>
+        </a:xfrm>
+      </p:grpSpPr>
+      <p:sp>
+        <p:nvSpPr>
+          <p:cNvPr id="2" name="Text 0"/>
+          <p:cNvSpPr/>
+          <p:nvPr/>
+        </p:nvSpPr>
+        <p:spPr>
+          <a:xfrm>
+            <a:off x="640080" y="365760"/>
+            <a:ext cx="8229600" cy="274320"/>
+          </a:xfrm>
+          <a:prstGeom prst="rect">
+            <a:avLst/>
+          </a:prstGeom>
+          <a:noFill/>
+          <a:ln/>
+        </p:spPr>
+        <p:txBody>
+          <a:bodyPr wrap="square" lIns="0" tIns="0" rIns="0" bIns="0" rtlCol="0" anchor="ctr"/>
+          <a:lstStyle/>
+          <a:p>
+            <a:pPr indent="0" marL="0">
+              <a:buNone/>
+            </a:pPr>
+            <a:r>
+              <a:rPr lang="en-US" sz="1100" b="1" spc="200" kern="0" dirty="0">
+                <a:solidFill>
+                  <a:srgbClr val="2BD9E5"/>
+                </a:solidFill>
+                <a:latin typeface="Arial" pitchFamily="34" charset="0"/>
+                <a:ea typeface="Arial" pitchFamily="34" charset="-122"/>
+                <a:cs typeface="Arial" pitchFamily="34" charset="-120"/>
+              </a:rPr>
+              <a:t>DA TENERE A MENTE</a:t>
+            </a:r>
+            <a:endParaRPr lang="en-US" sz="1100" dirty="0"/>
+          </a:p>
+        </p:txBody>
+      </p:sp>
+      <p:sp>
+        <p:nvSpPr>
+          <p:cNvPr id="3" name="Text 1"/>
+          <p:cNvSpPr/>
+          <p:nvPr/>
+        </p:nvSpPr>
+        <p:spPr>
+          <a:xfrm>
+            <a:off x="640080" y="640080"/>
+            <a:ext cx="7863840" cy="566928"/>
+          </a:xfrm>
+          <a:prstGeom prst="rect">
+            <a:avLst/>
+          </a:prstGeom>
+          <a:noFill/>
+          <a:ln/>
+        </p:spPr>
+        <p:txBody>
+          <a:bodyPr wrap="square" lIns="0" tIns="0" rIns="0" bIns="0" rtlCol="0" anchor="ctr"/>
+          <a:lstStyle/>
+          <a:p>
+            <a:pPr indent="0" marL="0">
+              <a:buNone/>
+            </a:pPr>
+            <a:r>
+              <a:rPr lang="en-US" sz="3000" dirty="0">
+                <a:solidFill>
+                  <a:srgbClr val="F4F7FF"/>
+                </a:solidFill>
+                <a:latin typeface="Arial Black" pitchFamily="34" charset="0"/>
+                <a:ea typeface="Arial Black" pitchFamily="34" charset="-122"/>
+                <a:cs typeface="Arial Black" pitchFamily="34" charset="-120"/>
+              </a:rPr>
+              <a:t>Tre accortezze trasversali</a:t>
+            </a:r>
+            <a:endParaRPr lang="en-US" sz="3000" dirty="0"/>
+          </a:p>
+        </p:txBody>
+      </p:sp>
+      <p:sp>
+        <p:nvSpPr>
+          <p:cNvPr id="4" name="Text 2"/>
+          <p:cNvSpPr/>
+          <p:nvPr/>
+        </p:nvSpPr>
+        <p:spPr>
+          <a:xfrm>
+            <a:off x="658368" y="1417320"/>
+            <a:ext cx="7772400" cy="914400"/>
+          </a:xfrm>
+          <a:prstGeom prst="rect">
+            <a:avLst/>
+          </a:prstGeom>
+          <a:noFill/>
+          <a:ln/>
+        </p:spPr>
+        <p:txBody>
+          <a:bodyPr wrap="square" lIns="0" tIns="0" rIns="0" bIns="0" rtlCol="0" anchor="ctr"/>
+          <a:lstStyle/>
+          <a:p>
+            <a:pPr indent="0" marL="0">
+              <a:lnSpc>
+                <a:spcPct val="130000"/>
+              </a:lnSpc>
+              <a:buNone/>
+            </a:pPr>
+            <a:r>
+              <a:rPr lang="en-US" sz="1800" dirty="0">
+                <a:solidFill>
+                  <a:srgbClr val="F4F7FF"/>
+                </a:solidFill>
+                <a:latin typeface="Arial" pitchFamily="34" charset="0"/>
+                <a:ea typeface="Arial" pitchFamily="34" charset="-122"/>
+                <a:cs typeface="Arial" pitchFamily="34" charset="-120"/>
+              </a:rPr>
+              <a:t>Non sono fasi in sequenza: sono </a:t>
+            </a:r>
+            <a:pPr indent="0" marL="0">
+              <a:lnSpc>
+                <a:spcPct val="130000"/>
+              </a:lnSpc>
+              <a:buNone/>
+            </a:pPr>
+            <a:r>
+              <a:rPr lang="en-US" sz="1800" b="1" dirty="0">
+                <a:solidFill>
+                  <a:srgbClr val="2BD9E5"/>
+                </a:solidFill>
+                <a:latin typeface="Arial" pitchFamily="34" charset="0"/>
+                <a:ea typeface="Arial" pitchFamily="34" charset="-122"/>
+                <a:cs typeface="Arial" pitchFamily="34" charset="-120"/>
+              </a:rPr>
+              <a:t>abitudini</a:t>
+            </a:r>
+            <a:pPr indent="0" marL="0">
+              <a:lnSpc>
+                <a:spcPct val="130000"/>
+              </a:lnSpc>
+              <a:buNone/>
+            </a:pPr>
+            <a:r>
+              <a:rPr lang="en-US" sz="1800" dirty="0">
+                <a:solidFill>
+                  <a:srgbClr val="F4F7FF"/>
+                </a:solidFill>
+                <a:latin typeface="Arial" pitchFamily="34" charset="0"/>
+                <a:ea typeface="Arial" pitchFamily="34" charset="-122"/>
+                <a:cs typeface="Arial" pitchFamily="34" charset="-120"/>
+              </a:rPr>
+              <a:t> valide a ogni modifica, che ti risparmiano tempo e brutte sorprese.</a:t>
+            </a:r>
+            <a:endParaRPr lang="en-US" sz="1800" dirty="0"/>
+          </a:p>
+        </p:txBody>
+      </p:sp>
+      <p:sp>
+        <p:nvSpPr>
+          <p:cNvPr id="5" name="Shape 3"/>
+          <p:cNvSpPr/>
+          <p:nvPr/>
+        </p:nvSpPr>
+        <p:spPr>
+          <a:xfrm>
+            <a:off x="640080" y="2834640"/>
+            <a:ext cx="2496312" cy="1691640"/>
+          </a:xfrm>
+          <a:prstGeom prst="roundRect">
+            <a:avLst>
+              <a:gd name="adj" fmla="val 4324"/>
+            </a:avLst>
+          </a:prstGeom>
+          <a:solidFill>
+            <a:srgbClr val="16203F"/>
+          </a:solidFill>
+          <a:ln w="13970">
+            <a:solidFill>
+              <a:srgbClr val="2BD9E5"/>
+            </a:solidFill>
+            <a:prstDash val="solid"/>
+          </a:ln>
+        </p:spPr>
+      </p:sp>
+      <p:sp>
+        <p:nvSpPr>
+          <p:cNvPr id="6" name="Shape 4"/>
+          <p:cNvSpPr/>
+          <p:nvPr/>
+        </p:nvSpPr>
+        <p:spPr>
+          <a:xfrm>
+            <a:off x="1645920" y="3063240"/>
+            <a:ext cx="502920" cy="502920"/>
+          </a:xfrm>
+          <a:prstGeom prst="ellipse">
+            <a:avLst/>
+          </a:prstGeom>
+          <a:solidFill>
+            <a:srgbClr val="0E3A44"/>
+          </a:solidFill>
+          <a:ln w="9525">
+            <a:solidFill>
+              <a:srgbClr val="2BD9E5"/>
+            </a:solidFill>
+            <a:prstDash val="solid"/>
+          </a:ln>
+        </p:spPr>
+      </p:sp>
+      <p:pic>
+        <p:nvPicPr>
+          <p:cNvPr id="7" name="Image 0" descr="preencoded.png">    </p:cNvPr>
+          <p:cNvPicPr>
+            <a:picLocks noChangeAspect="1"/>
+          </p:cNvPicPr>
+          <p:nvPr/>
+        </p:nvPicPr>
+        <p:blipFill>
+          <a:blip r:embed="rId1"/>
+          <a:stretch>
+            <a:fillRect/>
+          </a:stretch>
+        </p:blipFill>
+        <p:spPr>
+          <a:xfrm>
+            <a:off x="1781708" y="3199028"/>
+            <a:ext cx="231343" cy="231343"/>
+          </a:xfrm>
+          <a:prstGeom prst="rect">
+            <a:avLst/>
+          </a:prstGeom>
+        </p:spPr>
+      </p:pic>
+      <p:sp>
+        <p:nvSpPr>
+          <p:cNvPr id="8" name="Text 5"/>
+          <p:cNvSpPr/>
+          <p:nvPr/>
+        </p:nvSpPr>
+        <p:spPr>
+          <a:xfrm>
+            <a:off x="640080" y="3703320"/>
+            <a:ext cx="2496312" cy="365760"/>
+          </a:xfrm>
+          <a:prstGeom prst="rect">
+            <a:avLst/>
+          </a:prstGeom>
+          <a:noFill/>
+          <a:ln/>
+        </p:spPr>
+        <p:txBody>
+          <a:bodyPr wrap="square" lIns="0" tIns="0" rIns="0" bIns="0" rtlCol="0" anchor="ctr"/>
+          <a:lstStyle/>
+          <a:p>
+            <a:pPr algn="ctr" indent="0" marL="0">
+              <a:buNone/>
+            </a:pPr>
+            <a:r>
+              <a:rPr lang="en-US" sz="1600" b="1" dirty="0">
+                <a:solidFill>
+                  <a:srgbClr val="F4F7FF"/>
+                </a:solidFill>
+                <a:latin typeface="Arial" pitchFamily="34" charset="0"/>
+                <a:ea typeface="Arial" pitchFamily="34" charset="-122"/>
+                <a:cs typeface="Arial" pitchFamily="34" charset="-120"/>
+              </a:rPr>
+              <a:t>Testa sempre</a:t>
+            </a:r>
+            <a:endParaRPr lang="en-US" sz="1600" dirty="0"/>
+          </a:p>
+        </p:txBody>
+      </p:sp>
+      <p:sp>
+        <p:nvSpPr>
+          <p:cNvPr id="9" name="Text 6"/>
+          <p:cNvSpPr/>
+          <p:nvPr/>
+        </p:nvSpPr>
+        <p:spPr>
+          <a:xfrm>
+            <a:off x="640080" y="4069080"/>
+            <a:ext cx="2496312" cy="320040"/>
+          </a:xfrm>
+          <a:prstGeom prst="rect">
+            <a:avLst/>
+          </a:prstGeom>
+          <a:noFill/>
+          <a:ln/>
+        </p:spPr>
+        <p:txBody>
+          <a:bodyPr wrap="square" lIns="0" tIns="0" rIns="0" bIns="0" rtlCol="0" anchor="ctr"/>
+          <a:lstStyle/>
+          <a:p>
+            <a:pPr algn="ctr" indent="0" marL="0">
+              <a:buNone/>
+            </a:pPr>
+            <a:r>
+              <a:rPr lang="en-US" sz="1200" dirty="0">
+                <a:solidFill>
+                  <a:srgbClr val="AEBDE0"/>
+                </a:solidFill>
+                <a:latin typeface="Arial" pitchFamily="34" charset="0"/>
+                <a:ea typeface="Arial" pitchFamily="34" charset="-122"/>
+                <a:cs typeface="Arial" pitchFamily="34" charset="-120"/>
+              </a:rPr>
+              <a:t>doppia verifica</a:t>
+            </a:r>
+            <a:endParaRPr lang="en-US" sz="1200" dirty="0"/>
+          </a:p>
+        </p:txBody>
+      </p:sp>
+      <p:sp>
+        <p:nvSpPr>
+          <p:cNvPr id="10" name="Shape 7"/>
+          <p:cNvSpPr/>
+          <p:nvPr/>
+        </p:nvSpPr>
+        <p:spPr>
+          <a:xfrm>
+            <a:off x="3337560" y="2834640"/>
+            <a:ext cx="2496312" cy="1691640"/>
+          </a:xfrm>
+          <a:prstGeom prst="roundRect">
+            <a:avLst>
+              <a:gd name="adj" fmla="val 4324"/>
+            </a:avLst>
+          </a:prstGeom>
+          <a:solidFill>
+            <a:srgbClr val="16203F"/>
+          </a:solidFill>
+          <a:ln w="13970">
+            <a:solidFill>
+              <a:srgbClr val="2BD9E5"/>
+            </a:solidFill>
+            <a:prstDash val="solid"/>
+          </a:ln>
+        </p:spPr>
+      </p:sp>
+      <p:sp>
+        <p:nvSpPr>
+          <p:cNvPr id="11" name="Shape 8"/>
+          <p:cNvSpPr/>
+          <p:nvPr/>
+        </p:nvSpPr>
+        <p:spPr>
+          <a:xfrm>
+            <a:off x="4343400" y="3063240"/>
+            <a:ext cx="502920" cy="502920"/>
+          </a:xfrm>
+          <a:prstGeom prst="ellipse">
+            <a:avLst/>
+          </a:prstGeom>
+          <a:solidFill>
+            <a:srgbClr val="0E3A44"/>
+          </a:solidFill>
+          <a:ln w="9525">
+            <a:solidFill>
+              <a:srgbClr val="2BD9E5"/>
+            </a:solidFill>
+            <a:prstDash val="solid"/>
+          </a:ln>
+        </p:spPr>
+      </p:sp>
+      <p:pic>
+        <p:nvPicPr>
+          <p:cNvPr id="12" name="Image 1" descr="preencoded.png">    </p:cNvPr>
+          <p:cNvPicPr>
+            <a:picLocks noChangeAspect="1"/>
+          </p:cNvPicPr>
+          <p:nvPr/>
+        </p:nvPicPr>
+        <p:blipFill>
+          <a:blip r:embed="rId2"/>
+          <a:stretch>
+            <a:fillRect/>
+          </a:stretch>
+        </p:blipFill>
+        <p:spPr>
+          <a:xfrm>
+            <a:off x="4479188" y="3199028"/>
+            <a:ext cx="231343" cy="231343"/>
+          </a:xfrm>
+          <a:prstGeom prst="rect">
+            <a:avLst/>
+          </a:prstGeom>
+        </p:spPr>
+      </p:pic>
+      <p:sp>
+        <p:nvSpPr>
+          <p:cNvPr id="13" name="Text 9"/>
+          <p:cNvSpPr/>
+          <p:nvPr/>
+        </p:nvSpPr>
+        <p:spPr>
+          <a:xfrm>
+            <a:off x="3337560" y="3703320"/>
+            <a:ext cx="2496312" cy="365760"/>
+          </a:xfrm>
+          <a:prstGeom prst="rect">
+            <a:avLst/>
+          </a:prstGeom>
+          <a:noFill/>
+          <a:ln/>
+        </p:spPr>
+        <p:txBody>
+          <a:bodyPr wrap="square" lIns="0" tIns="0" rIns="0" bIns="0" rtlCol="0" anchor="ctr"/>
+          <a:lstStyle/>
+          <a:p>
+            <a:pPr algn="ctr" indent="0" marL="0">
+              <a:buNone/>
+            </a:pPr>
+            <a:r>
+              <a:rPr lang="en-US" sz="1600" b="1" dirty="0">
+                <a:solidFill>
+                  <a:srgbClr val="F4F7FF"/>
+                </a:solidFill>
+                <a:latin typeface="Arial" pitchFamily="34" charset="0"/>
+                <a:ea typeface="Arial" pitchFamily="34" charset="-122"/>
+                <a:cs typeface="Arial" pitchFamily="34" charset="-120"/>
+              </a:rPr>
+              <a:t>Occhio alla build</a:t>
+            </a:r>
+            <a:endParaRPr lang="en-US" sz="1600" dirty="0"/>
+          </a:p>
+        </p:txBody>
+      </p:sp>
+      <p:sp>
+        <p:nvSpPr>
+          <p:cNvPr id="14" name="Text 10"/>
+          <p:cNvSpPr/>
+          <p:nvPr/>
+        </p:nvSpPr>
+        <p:spPr>
+          <a:xfrm>
+            <a:off x="3337560" y="4069080"/>
+            <a:ext cx="2496312" cy="320040"/>
+          </a:xfrm>
+          <a:prstGeom prst="rect">
+            <a:avLst/>
+          </a:prstGeom>
+          <a:noFill/>
+          <a:ln/>
+        </p:spPr>
+        <p:txBody>
+          <a:bodyPr wrap="square" lIns="0" tIns="0" rIns="0" bIns="0" rtlCol="0" anchor="ctr"/>
+          <a:lstStyle/>
+          <a:p>
+            <a:pPr algn="ctr" indent="0" marL="0">
+              <a:buNone/>
+            </a:pPr>
+            <a:r>
+              <a:rPr lang="en-US" sz="1200" dirty="0">
+                <a:solidFill>
+                  <a:srgbClr val="AEBDE0"/>
+                </a:solidFill>
+                <a:latin typeface="Arial" pitchFamily="34" charset="0"/>
+                <a:ea typeface="Arial" pitchFamily="34" charset="-122"/>
+                <a:cs typeface="Arial" pitchFamily="34" charset="-120"/>
+              </a:rPr>
+              <a:t>tempo e CPU</a:t>
+            </a:r>
+            <a:endParaRPr lang="en-US" sz="1200" dirty="0"/>
+          </a:p>
+        </p:txBody>
+      </p:sp>
+      <p:sp>
+        <p:nvSpPr>
+          <p:cNvPr id="15" name="Shape 11"/>
+          <p:cNvSpPr/>
+          <p:nvPr/>
+        </p:nvSpPr>
+        <p:spPr>
+          <a:xfrm>
+            <a:off x="6035040" y="2834640"/>
+            <a:ext cx="2496312" cy="1691640"/>
+          </a:xfrm>
+          <a:prstGeom prst="roundRect">
+            <a:avLst>
+              <a:gd name="adj" fmla="val 4324"/>
+            </a:avLst>
+          </a:prstGeom>
+          <a:solidFill>
+            <a:srgbClr val="16203F"/>
+          </a:solidFill>
+          <a:ln w="13970">
+            <a:solidFill>
+              <a:srgbClr val="2BD9E5"/>
+            </a:solidFill>
+            <a:prstDash val="solid"/>
+          </a:ln>
+        </p:spPr>
+      </p:sp>
+      <p:sp>
+        <p:nvSpPr>
+          <p:cNvPr id="16" name="Shape 12"/>
+          <p:cNvSpPr/>
+          <p:nvPr/>
+        </p:nvSpPr>
+        <p:spPr>
+          <a:xfrm>
+            <a:off x="7040880" y="3063240"/>
+            <a:ext cx="502920" cy="502920"/>
+          </a:xfrm>
+          <a:prstGeom prst="ellipse">
+            <a:avLst/>
+          </a:prstGeom>
+          <a:solidFill>
+            <a:srgbClr val="0E3A44"/>
+          </a:solidFill>
+          <a:ln w="9525">
+            <a:solidFill>
+              <a:srgbClr val="2BD9E5"/>
+            </a:solidFill>
+            <a:prstDash val="solid"/>
+          </a:ln>
+        </p:spPr>
+      </p:sp>
+      <p:pic>
+        <p:nvPicPr>
+          <p:cNvPr id="17" name="Image 2" descr="preencoded.png">    </p:cNvPr>
+          <p:cNvPicPr>
+            <a:picLocks noChangeAspect="1"/>
+          </p:cNvPicPr>
+          <p:nvPr/>
+        </p:nvPicPr>
+        <p:blipFill>
+          <a:blip r:embed="rId3"/>
+          <a:stretch>
+            <a:fillRect/>
+          </a:stretch>
+        </p:blipFill>
+        <p:spPr>
+          <a:xfrm>
+            <a:off x="7176668" y="3199028"/>
+            <a:ext cx="231343" cy="231343"/>
+          </a:xfrm>
+          <a:prstGeom prst="rect">
+            <a:avLst/>
+          </a:prstGeom>
+        </p:spPr>
+      </p:pic>
+      <p:sp>
+        <p:nvSpPr>
+          <p:cNvPr id="18" name="Text 13"/>
+          <p:cNvSpPr/>
+          <p:nvPr/>
+        </p:nvSpPr>
+        <p:spPr>
+          <a:xfrm>
+            <a:off x="6035040" y="3703320"/>
+            <a:ext cx="2496312" cy="365760"/>
+          </a:xfrm>
+          <a:prstGeom prst="rect">
+            <a:avLst/>
+          </a:prstGeom>
+          <a:noFill/>
+          <a:ln/>
+        </p:spPr>
+        <p:txBody>
+          <a:bodyPr wrap="square" lIns="0" tIns="0" rIns="0" bIns="0" rtlCol="0" anchor="ctr"/>
+          <a:lstStyle/>
+          <a:p>
+            <a:pPr algn="ctr" indent="0" marL="0">
+              <a:buNone/>
+            </a:pPr>
+            <a:r>
+              <a:rPr lang="en-US" sz="1600" b="1" dirty="0">
+                <a:solidFill>
+                  <a:srgbClr val="F4F7FF"/>
+                </a:solidFill>
+                <a:latin typeface="Arial" pitchFamily="34" charset="0"/>
+                <a:ea typeface="Arial" pitchFamily="34" charset="-122"/>
+                <a:cs typeface="Arial" pitchFamily="34" charset="-120"/>
+              </a:rPr>
+              <a:t>Leggi le regole</a:t>
+            </a:r>
+            <a:endParaRPr lang="en-US" sz="1600" dirty="0"/>
+          </a:p>
+        </p:txBody>
+      </p:sp>
+      <p:sp>
+        <p:nvSpPr>
+          <p:cNvPr id="19" name="Text 14"/>
+          <p:cNvSpPr/>
+          <p:nvPr/>
+        </p:nvSpPr>
+        <p:spPr>
+          <a:xfrm>
+            <a:off x="6035040" y="4069080"/>
+            <a:ext cx="2496312" cy="320040"/>
+          </a:xfrm>
+          <a:prstGeom prst="rect">
+            <a:avLst/>
+          </a:prstGeom>
+          <a:noFill/>
+          <a:ln/>
+        </p:spPr>
+        <p:txBody>
+          <a:bodyPr wrap="square" lIns="0" tIns="0" rIns="0" bIns="0" rtlCol="0" anchor="ctr"/>
+          <a:lstStyle/>
+          <a:p>
+            <a:pPr algn="ctr" indent="0" marL="0">
+              <a:buNone/>
+            </a:pPr>
+            <a:r>
+              <a:rPr lang="en-US" sz="1200" dirty="0">
+                <a:solidFill>
+                  <a:srgbClr val="AEBDE0"/>
+                </a:solidFill>
+                <a:latin typeface="Arial" pitchFamily="34" charset="0"/>
+                <a:ea typeface="Arial" pitchFamily="34" charset="-122"/>
+                <a:cs typeface="Arial" pitchFamily="34" charset="-120"/>
+              </a:rPr>
+              <a:t>dello store</a:t>
+            </a:r>
+            <a:endParaRPr lang="en-US" sz="1200" dirty="0"/>
+          </a:p>
+        </p:txBody>
+      </p:sp>
+    </p:spTree>
+  </p:cSld>
+  <p:clrMapOvr>
+    <a:masterClrMapping/>
+  </p:clrMapOvr>
+</p:sld>
+</file>
+
+<file path=ppt/slides/slide24.xml><?xml version="1.0" encoding="utf-8"?>
+<p:sld xmlns:a="http://schemas.openxmlformats.org/drawingml/2006/main" xmlns:r="http://schemas.openxmlformats.org/officeDocument/2006/relationships" xmlns:p="http://schemas.openxmlformats.org/presentationml/2006/main">
+  <p:cSld name="Slide 24">
+    <p:bg>
+      <p:bgPr>
+        <a:solidFill>
+          <a:srgbClr val="0B1226"/>
+        </a:solidFill>
+      </p:bgPr>
+    </p:bg>
+    <p:spTree>
+      <p:nvGrpSpPr>
+        <p:cNvPr id="1" name=""/>
+        <p:cNvGrpSpPr/>
+        <p:nvPr/>
+      </p:nvGrpSpPr>
+      <p:grpSpPr>
+        <a:xfrm>
+          <a:off x="0" y="0"/>
+          <a:ext cx="0" cy="0"/>
+          <a:chOff x="0" y="0"/>
+          <a:chExt cx="0" cy="0"/>
+        </a:xfrm>
+      </p:grpSpPr>
+      <p:sp>
+        <p:nvSpPr>
+          <p:cNvPr id="2" name="Text 0"/>
+          <p:cNvSpPr/>
+          <p:nvPr/>
+        </p:nvSpPr>
+        <p:spPr>
+          <a:xfrm>
+            <a:off x="640080" y="365760"/>
+            <a:ext cx="8229600" cy="274320"/>
+          </a:xfrm>
+          <a:prstGeom prst="rect">
+            <a:avLst/>
+          </a:prstGeom>
+          <a:noFill/>
+          <a:ln/>
+        </p:spPr>
+        <p:txBody>
+          <a:bodyPr wrap="square" lIns="0" tIns="0" rIns="0" bIns="0" rtlCol="0" anchor="ctr"/>
+          <a:lstStyle/>
+          <a:p>
+            <a:pPr indent="0" marL="0">
+              <a:buNone/>
+            </a:pPr>
+            <a:r>
+              <a:rPr lang="en-US" sz="1100" b="1" spc="200" kern="0" dirty="0">
+                <a:solidFill>
+                  <a:srgbClr val="2BD9E5"/>
+                </a:solidFill>
+                <a:latin typeface="Arial" pitchFamily="34" charset="0"/>
+                <a:ea typeface="Arial" pitchFamily="34" charset="-122"/>
+                <a:cs typeface="Arial" pitchFamily="34" charset="-120"/>
+              </a:rPr>
+              <a:t>DA TENERE A MENTE · 1 · TESTA SEMPRE</a:t>
+            </a:r>
+            <a:endParaRPr lang="en-US" sz="1100" dirty="0"/>
+          </a:p>
+        </p:txBody>
+      </p:sp>
+      <p:sp>
+        <p:nvSpPr>
+          <p:cNvPr id="3" name="Text 1"/>
+          <p:cNvSpPr/>
+          <p:nvPr/>
+        </p:nvSpPr>
+        <p:spPr>
+          <a:xfrm>
+            <a:off x="640080" y="640080"/>
+            <a:ext cx="7863840" cy="566928"/>
+          </a:xfrm>
+          <a:prstGeom prst="rect">
+            <a:avLst/>
+          </a:prstGeom>
+          <a:noFill/>
+          <a:ln/>
+        </p:spPr>
+        <p:txBody>
+          <a:bodyPr wrap="square" lIns="0" tIns="0" rIns="0" bIns="0" rtlCol="0" anchor="ctr"/>
+          <a:lstStyle/>
+          <a:p>
+            <a:pPr indent="0" marL="0">
+              <a:buNone/>
+            </a:pPr>
+            <a:r>
+              <a:rPr lang="en-US" sz="3000" dirty="0">
+                <a:solidFill>
+                  <a:srgbClr val="F4F7FF"/>
+                </a:solidFill>
+                <a:latin typeface="Arial Black" pitchFamily="34" charset="0"/>
+                <a:ea typeface="Arial Black" pitchFamily="34" charset="-122"/>
+                <a:cs typeface="Arial Black" pitchFamily="34" charset="-120"/>
+              </a:rPr>
+              <a:t>Testa sempre</a:t>
+            </a:r>
+            <a:endParaRPr lang="en-US" sz="3000" dirty="0"/>
+          </a:p>
+        </p:txBody>
+      </p:sp>
+      <p:sp>
+        <p:nvSpPr>
+          <p:cNvPr id="4" name="Text 2"/>
+          <p:cNvSpPr/>
+          <p:nvPr/>
+        </p:nvSpPr>
+        <p:spPr>
+          <a:xfrm>
+            <a:off x="658368" y="1188720"/>
+            <a:ext cx="7772400" cy="310896"/>
+          </a:xfrm>
+          <a:prstGeom prst="rect">
+            <a:avLst/>
+          </a:prstGeom>
+          <a:noFill/>
+          <a:ln/>
+        </p:spPr>
+        <p:txBody>
+          <a:bodyPr wrap="square" lIns="0" tIns="0" rIns="0" bIns="0" rtlCol="0" anchor="ctr"/>
+          <a:lstStyle/>
+          <a:p>
+            <a:pPr indent="0" marL="0">
+              <a:buNone/>
+            </a:pPr>
+            <a:r>
+              <a:rPr lang="en-US" sz="1350" i="1" dirty="0">
+                <a:solidFill>
+                  <a:srgbClr val="AEBDE0"/>
+                </a:solidFill>
+                <a:latin typeface="Arial" pitchFamily="34" charset="0"/>
+                <a:ea typeface="Arial" pitchFamily="34" charset="-122"/>
+                <a:cs typeface="Arial" pitchFamily="34" charset="-120"/>
+              </a:rPr>
+              <a:t>Niente va online senza una verifica doppia.</a:t>
+            </a:r>
+            <a:endParaRPr lang="en-US" sz="1350" dirty="0"/>
+          </a:p>
+        </p:txBody>
+      </p:sp>
+      <p:sp>
+        <p:nvSpPr>
+          <p:cNvPr id="5" name="Shape 3"/>
+          <p:cNvSpPr/>
+          <p:nvPr/>
+        </p:nvSpPr>
+        <p:spPr>
+          <a:xfrm>
+            <a:off x="640080" y="1737360"/>
+            <a:ext cx="3794760" cy="2194560"/>
+          </a:xfrm>
+          <a:prstGeom prst="roundRect">
+            <a:avLst>
+              <a:gd name="adj" fmla="val 3333"/>
+            </a:avLst>
+          </a:prstGeom>
+          <a:solidFill>
+            <a:srgbClr val="16203F"/>
+          </a:solidFill>
+          <a:ln w="9525">
+            <a:solidFill>
+              <a:srgbClr val="2A3A6B"/>
+            </a:solidFill>
+            <a:prstDash val="solid"/>
+          </a:ln>
+        </p:spPr>
+      </p:sp>
+      <p:sp>
+        <p:nvSpPr>
+          <p:cNvPr id="6" name="Shape 4"/>
+          <p:cNvSpPr/>
+          <p:nvPr/>
+        </p:nvSpPr>
+        <p:spPr>
+          <a:xfrm>
+            <a:off x="868680" y="1965960"/>
+            <a:ext cx="502920" cy="502920"/>
+          </a:xfrm>
+          <a:prstGeom prst="ellipse">
+            <a:avLst/>
+          </a:prstGeom>
+          <a:solidFill>
+            <a:srgbClr val="0E3A44"/>
+          </a:solidFill>
+          <a:ln w="12700">
+            <a:solidFill>
+              <a:srgbClr val="0E3A44"/>
+            </a:solidFill>
+            <a:prstDash val="solid"/>
+          </a:ln>
+        </p:spPr>
+      </p:sp>
+      <p:pic>
+        <p:nvPicPr>
+          <p:cNvPr id="7" name="Image 0" descr="preencoded.png">    </p:cNvPr>
+          <p:cNvPicPr>
+            <a:picLocks noChangeAspect="1"/>
+          </p:cNvPicPr>
+          <p:nvPr/>
+        </p:nvPicPr>
+        <p:blipFill>
+          <a:blip r:embed="rId1"/>
+          <a:stretch>
+            <a:fillRect/>
+          </a:stretch>
+        </p:blipFill>
+        <p:spPr>
+          <a:xfrm>
+            <a:off x="1004468" y="2101748"/>
+            <a:ext cx="231343" cy="231343"/>
+          </a:xfrm>
+          <a:prstGeom prst="rect">
+            <a:avLst/>
+          </a:prstGeom>
+        </p:spPr>
+      </p:pic>
+      <p:sp>
+        <p:nvSpPr>
+          <p:cNvPr id="8" name="Text 5"/>
+          <p:cNvSpPr/>
+          <p:nvPr/>
+        </p:nvSpPr>
+        <p:spPr>
+          <a:xfrm>
+            <a:off x="1508760" y="1965960"/>
+            <a:ext cx="2743200" cy="502920"/>
+          </a:xfrm>
+          <a:prstGeom prst="rect">
+            <a:avLst/>
+          </a:prstGeom>
+          <a:noFill/>
+          <a:ln/>
+        </p:spPr>
+        <p:txBody>
+          <a:bodyPr wrap="square" lIns="0" tIns="0" rIns="0" bIns="0" rtlCol="0" anchor="ctr"/>
+          <a:lstStyle/>
+          <a:p>
+            <a:pPr indent="0" marL="0">
+              <a:buNone/>
+            </a:pPr>
+            <a:r>
+              <a:rPr lang="en-US" sz="1500" b="1" dirty="0">
+                <a:solidFill>
+                  <a:srgbClr val="F4F7FF"/>
+                </a:solidFill>
+                <a:latin typeface="Arial" pitchFamily="34" charset="0"/>
+                <a:ea typeface="Arial" pitchFamily="34" charset="-122"/>
+                <a:cs typeface="Arial" pitchFamily="34" charset="-120"/>
+              </a:rPr>
+              <a:t>Fallo provare a Claude</a:t>
+            </a:r>
+            <a:endParaRPr lang="en-US" sz="1500" dirty="0"/>
+          </a:p>
+        </p:txBody>
+      </p:sp>
+      <p:sp>
+        <p:nvSpPr>
+          <p:cNvPr id="9" name="Text 6"/>
+          <p:cNvSpPr/>
+          <p:nvPr/>
+        </p:nvSpPr>
+        <p:spPr>
+          <a:xfrm>
+            <a:off x="868680" y="2578608"/>
+            <a:ext cx="3337560" cy="1234440"/>
+          </a:xfrm>
+          <a:prstGeom prst="rect">
+            <a:avLst/>
+          </a:prstGeom>
+          <a:noFill/>
+          <a:ln/>
+        </p:spPr>
+        <p:txBody>
+          <a:bodyPr wrap="square" lIns="0" tIns="0" rIns="0" bIns="0" rtlCol="0" anchor="t"/>
+          <a:lstStyle/>
+          <a:p>
+            <a:pPr indent="0" marL="0">
+              <a:lnSpc>
+                <a:spcPct val="118000"/>
+              </a:lnSpc>
+              <a:buNone/>
+            </a:pPr>
+            <a:r>
+              <a:rPr lang="en-US" sz="1150" dirty="0">
+                <a:solidFill>
+                  <a:srgbClr val="AEBDE0"/>
+                </a:solidFill>
+                <a:latin typeface="Arial" pitchFamily="34" charset="0"/>
+                <a:ea typeface="Arial" pitchFamily="34" charset="-122"/>
+                <a:cs typeface="Arial" pitchFamily="34" charset="-120"/>
+              </a:rPr>
+              <a:t>Ogni volta che finalizzi una modifica, almeno un test automatico: Claude installa l'app, la prova e verifica che funzioni.</a:t>
+            </a:r>
+            <a:endParaRPr lang="en-US" sz="1150" dirty="0"/>
+          </a:p>
+        </p:txBody>
+      </p:sp>
+      <p:sp>
+        <p:nvSpPr>
+          <p:cNvPr id="10" name="Shape 7"/>
+          <p:cNvSpPr/>
+          <p:nvPr/>
+        </p:nvSpPr>
+        <p:spPr>
+          <a:xfrm>
+            <a:off x="4709160" y="1737360"/>
+            <a:ext cx="3794760" cy="2194560"/>
+          </a:xfrm>
+          <a:prstGeom prst="roundRect">
+            <a:avLst>
+              <a:gd name="adj" fmla="val 3333"/>
+            </a:avLst>
+          </a:prstGeom>
+          <a:solidFill>
+            <a:srgbClr val="16203F"/>
+          </a:solidFill>
+          <a:ln w="9525">
+            <a:solidFill>
+              <a:srgbClr val="2A3A6B"/>
+            </a:solidFill>
+            <a:prstDash val="solid"/>
+          </a:ln>
+        </p:spPr>
+      </p:sp>
+      <p:sp>
+        <p:nvSpPr>
+          <p:cNvPr id="11" name="Shape 8"/>
+          <p:cNvSpPr/>
+          <p:nvPr/>
+        </p:nvSpPr>
+        <p:spPr>
+          <a:xfrm>
+            <a:off x="4937760" y="1965960"/>
+            <a:ext cx="502920" cy="502920"/>
+          </a:xfrm>
+          <a:prstGeom prst="ellipse">
+            <a:avLst/>
+          </a:prstGeom>
+          <a:solidFill>
+            <a:srgbClr val="0E3A44"/>
+          </a:solidFill>
+          <a:ln w="12700">
+            <a:solidFill>
+              <a:srgbClr val="0E3A44"/>
+            </a:solidFill>
+            <a:prstDash val="solid"/>
+          </a:ln>
+        </p:spPr>
+      </p:sp>
+      <p:pic>
+        <p:nvPicPr>
+          <p:cNvPr id="12" name="Image 1" descr="preencoded.png">    </p:cNvPr>
+          <p:cNvPicPr>
+            <a:picLocks noChangeAspect="1"/>
+          </p:cNvPicPr>
+          <p:nvPr/>
+        </p:nvPicPr>
+        <p:blipFill>
+          <a:blip r:embed="rId2"/>
+          <a:stretch>
+            <a:fillRect/>
+          </a:stretch>
+        </p:blipFill>
+        <p:spPr>
+          <a:xfrm>
+            <a:off x="5073548" y="2101748"/>
+            <a:ext cx="231343" cy="231343"/>
+          </a:xfrm>
+          <a:prstGeom prst="rect">
+            <a:avLst/>
+          </a:prstGeom>
+        </p:spPr>
+      </p:pic>
+      <p:sp>
+        <p:nvSpPr>
+          <p:cNvPr id="13" name="Text 9"/>
+          <p:cNvSpPr/>
+          <p:nvPr/>
+        </p:nvSpPr>
+        <p:spPr>
+          <a:xfrm>
+            <a:off x="5577840" y="1965960"/>
+            <a:ext cx="2743200" cy="502920"/>
+          </a:xfrm>
+          <a:prstGeom prst="rect">
+            <a:avLst/>
+          </a:prstGeom>
+          <a:noFill/>
+          <a:ln/>
+        </p:spPr>
+        <p:txBody>
+          <a:bodyPr wrap="square" lIns="0" tIns="0" rIns="0" bIns="0" rtlCol="0" anchor="ctr"/>
+          <a:lstStyle/>
+          <a:p>
+            <a:pPr indent="0" marL="0">
+              <a:buNone/>
+            </a:pPr>
+            <a:r>
+              <a:rPr lang="en-US" sz="1500" b="1" dirty="0">
+                <a:solidFill>
+                  <a:srgbClr val="F4F7FF"/>
+                </a:solidFill>
+                <a:latin typeface="Arial" pitchFamily="34" charset="0"/>
+                <a:ea typeface="Arial" pitchFamily="34" charset="-122"/>
+                <a:cs typeface="Arial" pitchFamily="34" charset="-120"/>
+              </a:rPr>
+              <a:t>Dai l'occhiata finale</a:t>
+            </a:r>
+            <a:endParaRPr lang="en-US" sz="1500" dirty="0"/>
+          </a:p>
+        </p:txBody>
+      </p:sp>
+      <p:sp>
+        <p:nvSpPr>
+          <p:cNvPr id="14" name="Text 10"/>
+          <p:cNvSpPr/>
+          <p:nvPr/>
+        </p:nvSpPr>
+        <p:spPr>
+          <a:xfrm>
+            <a:off x="4937760" y="2578608"/>
+            <a:ext cx="3337560" cy="1234440"/>
+          </a:xfrm>
+          <a:prstGeom prst="rect">
+            <a:avLst/>
+          </a:prstGeom>
+          <a:noFill/>
+          <a:ln/>
+        </p:spPr>
+        <p:txBody>
+          <a:bodyPr wrap="square" lIns="0" tIns="0" rIns="0" bIns="0" rtlCol="0" anchor="t"/>
+          <a:lstStyle/>
+          <a:p>
+            <a:pPr indent="0" marL="0">
+              <a:lnSpc>
+                <a:spcPct val="118000"/>
+              </a:lnSpc>
+              <a:buNone/>
+            </a:pPr>
+            <a:r>
+              <a:rPr lang="en-US" sz="1150" dirty="0">
+                <a:solidFill>
+                  <a:srgbClr val="AEBDE0"/>
+                </a:solidFill>
+                <a:latin typeface="Arial" pitchFamily="34" charset="0"/>
+                <a:ea typeface="Arial" pitchFamily="34" charset="-122"/>
+                <a:cs typeface="Arial" pitchFamily="34" charset="-120"/>
+              </a:rPr>
+              <a:t>Poi sempre un controllo umano, tuo, prima di pubblicare. L'ultimo sguardo lo dai tu.</a:t>
+            </a:r>
+            <a:endParaRPr lang="en-US" sz="1150" dirty="0"/>
+          </a:p>
+        </p:txBody>
+      </p:sp>
+      <p:sp>
+        <p:nvSpPr>
+          <p:cNvPr id="15" name="Shape 11"/>
+          <p:cNvSpPr/>
+          <p:nvPr/>
+        </p:nvSpPr>
+        <p:spPr>
+          <a:xfrm>
+            <a:off x="640080" y="4160520"/>
+            <a:ext cx="7863840" cy="566928"/>
+          </a:xfrm>
+          <a:prstGeom prst="roundRect">
+            <a:avLst>
+              <a:gd name="adj" fmla="val 9677"/>
+            </a:avLst>
+          </a:prstGeom>
+          <a:solidFill>
+            <a:srgbClr val="0E3A44"/>
+          </a:solidFill>
+          <a:ln w="6350">
+            <a:solidFill>
+              <a:srgbClr val="2BD9E5"/>
+            </a:solidFill>
+            <a:prstDash val="solid"/>
+          </a:ln>
+        </p:spPr>
+      </p:sp>
+      <p:sp>
+        <p:nvSpPr>
+          <p:cNvPr id="16" name="Text 12"/>
+          <p:cNvSpPr/>
+          <p:nvPr/>
+        </p:nvSpPr>
+        <p:spPr>
+          <a:xfrm>
+            <a:off x="822960" y="4160520"/>
+            <a:ext cx="7498080" cy="566928"/>
+          </a:xfrm>
+          <a:prstGeom prst="rect">
+            <a:avLst/>
+          </a:prstGeom>
+          <a:noFill/>
+          <a:ln/>
+        </p:spPr>
+        <p:txBody>
+          <a:bodyPr wrap="square" lIns="0" tIns="0" rIns="0" bIns="0" rtlCol="0" anchor="ctr"/>
+          <a:lstStyle/>
+          <a:p>
+            <a:pPr algn="ctr" indent="0" marL="0">
+              <a:buNone/>
+            </a:pPr>
+            <a:r>
+              <a:rPr lang="en-US" sz="1250" dirty="0">
+                <a:solidFill>
+                  <a:srgbClr val="F4F7FF"/>
+                </a:solidFill>
+                <a:latin typeface="Arial" pitchFamily="34" charset="0"/>
+                <a:ea typeface="Arial" pitchFamily="34" charset="-122"/>
+                <a:cs typeface="Arial" pitchFamily="34" charset="-120"/>
+              </a:rPr>
+              <a:t>Una modifica finalizzata = un test di Claude + un'occhiata tua, ogni volta.</a:t>
+            </a:r>
+            <a:endParaRPr lang="en-US" sz="1250" dirty="0"/>
+          </a:p>
+        </p:txBody>
+      </p:sp>
+    </p:spTree>
+  </p:cSld>
+  <p:clrMapOvr>
+    <a:masterClrMapping/>
+  </p:clrMapOvr>
+</p:sld>
+</file>
+
+<file path=ppt/slides/slide25.xml><?xml version="1.0" encoding="utf-8"?>
+<p:sld xmlns:a="http://schemas.openxmlformats.org/drawingml/2006/main" xmlns:r="http://schemas.openxmlformats.org/officeDocument/2006/relationships" xmlns:p="http://schemas.openxmlformats.org/presentationml/2006/main">
+  <p:cSld name="Slide 25">
+    <p:bg>
+      <p:bgPr>
+        <a:solidFill>
+          <a:srgbClr val="0B1226"/>
+        </a:solidFill>
+      </p:bgPr>
+    </p:bg>
+    <p:spTree>
+      <p:nvGrpSpPr>
+        <p:cNvPr id="1" name=""/>
+        <p:cNvGrpSpPr/>
+        <p:nvPr/>
+      </p:nvGrpSpPr>
+      <p:grpSpPr>
+        <a:xfrm>
+          <a:off x="0" y="0"/>
+          <a:ext cx="0" cy="0"/>
+          <a:chOff x="0" y="0"/>
+          <a:chExt cx="0" cy="0"/>
+        </a:xfrm>
+      </p:grpSpPr>
+      <p:sp>
+        <p:nvSpPr>
+          <p:cNvPr id="2" name="Text 0"/>
+          <p:cNvSpPr/>
+          <p:nvPr/>
+        </p:nvSpPr>
+        <p:spPr>
+          <a:xfrm>
+            <a:off x="640080" y="365760"/>
+            <a:ext cx="8229600" cy="274320"/>
+          </a:xfrm>
+          <a:prstGeom prst="rect">
+            <a:avLst/>
+          </a:prstGeom>
+          <a:noFill/>
+          <a:ln/>
+        </p:spPr>
+        <p:txBody>
+          <a:bodyPr wrap="square" lIns="0" tIns="0" rIns="0" bIns="0" rtlCol="0" anchor="ctr"/>
+          <a:lstStyle/>
+          <a:p>
+            <a:pPr indent="0" marL="0">
+              <a:buNone/>
+            </a:pPr>
+            <a:r>
+              <a:rPr lang="en-US" sz="1100" b="1" spc="200" kern="0" dirty="0">
+                <a:solidFill>
+                  <a:srgbClr val="2BD9E5"/>
+                </a:solidFill>
+                <a:latin typeface="Arial" pitchFamily="34" charset="0"/>
+                <a:ea typeface="Arial" pitchFamily="34" charset="-122"/>
+                <a:cs typeface="Arial" pitchFamily="34" charset="-120"/>
+              </a:rPr>
+              <a:t>DA TENERE A MENTE · 2 · OCCHIO ALLA BUILD</a:t>
+            </a:r>
+            <a:endParaRPr lang="en-US" sz="1100" dirty="0"/>
+          </a:p>
+        </p:txBody>
+      </p:sp>
+      <p:sp>
+        <p:nvSpPr>
+          <p:cNvPr id="3" name="Text 1"/>
+          <p:cNvSpPr/>
+          <p:nvPr/>
+        </p:nvSpPr>
+        <p:spPr>
+          <a:xfrm>
+            <a:off x="640080" y="640080"/>
+            <a:ext cx="7863840" cy="566928"/>
+          </a:xfrm>
+          <a:prstGeom prst="rect">
+            <a:avLst/>
+          </a:prstGeom>
+          <a:noFill/>
+          <a:ln/>
+        </p:spPr>
+        <p:txBody>
+          <a:bodyPr wrap="square" lIns="0" tIns="0" rIns="0" bIns="0" rtlCol="0" anchor="ctr"/>
+          <a:lstStyle/>
+          <a:p>
+            <a:pPr indent="0" marL="0">
+              <a:buNone/>
+            </a:pPr>
+            <a:r>
+              <a:rPr lang="en-US" sz="3000" dirty="0">
+                <a:solidFill>
+                  <a:srgbClr val="F4F7FF"/>
+                </a:solidFill>
+                <a:latin typeface="Arial Black" pitchFamily="34" charset="0"/>
+                <a:ea typeface="Arial Black" pitchFamily="34" charset="-122"/>
+                <a:cs typeface="Arial Black" pitchFamily="34" charset="-120"/>
+              </a:rPr>
+              <a:t>Occhio alla compilazione</a:t>
+            </a:r>
+            <a:endParaRPr lang="en-US" sz="3000" dirty="0"/>
+          </a:p>
+        </p:txBody>
+      </p:sp>
+      <p:sp>
+        <p:nvSpPr>
+          <p:cNvPr id="4" name="Text 2"/>
+          <p:cNvSpPr/>
+          <p:nvPr/>
+        </p:nvSpPr>
+        <p:spPr>
+          <a:xfrm>
+            <a:off x="658368" y="1188720"/>
+            <a:ext cx="7772400" cy="310896"/>
+          </a:xfrm>
+          <a:prstGeom prst="rect">
+            <a:avLst/>
+          </a:prstGeom>
+          <a:noFill/>
+          <a:ln/>
+        </p:spPr>
+        <p:txBody>
+          <a:bodyPr wrap="square" lIns="0" tIns="0" rIns="0" bIns="0" rtlCol="0" anchor="ctr"/>
+          <a:lstStyle/>
+          <a:p>
+            <a:pPr indent="0" marL="0">
+              <a:buNone/>
+            </a:pPr>
+            <a:r>
+              <a:rPr lang="en-US" sz="1350" i="1" dirty="0">
+                <a:solidFill>
+                  <a:srgbClr val="AEBDE0"/>
+                </a:solidFill>
+                <a:latin typeface="Arial" pitchFamily="34" charset="0"/>
+                <a:ea typeface="Arial" pitchFamily="34" charset="-122"/>
+                <a:cs typeface="Arial" pitchFamily="34" charset="-120"/>
+              </a:rPr>
+              <a:t>Compilare l'app costa minuti e CPU: trattala come una risorsa preziosa.</a:t>
+            </a:r>
+            <a:endParaRPr lang="en-US" sz="1350" dirty="0"/>
+          </a:p>
+        </p:txBody>
+      </p:sp>
+      <p:sp>
+        <p:nvSpPr>
+          <p:cNvPr id="5" name="Shape 3"/>
+          <p:cNvSpPr/>
+          <p:nvPr/>
+        </p:nvSpPr>
+        <p:spPr>
+          <a:xfrm>
+            <a:off x="640080" y="1737360"/>
+            <a:ext cx="3794760" cy="2194560"/>
+          </a:xfrm>
+          <a:prstGeom prst="roundRect">
+            <a:avLst>
+              <a:gd name="adj" fmla="val 3333"/>
+            </a:avLst>
+          </a:prstGeom>
+          <a:solidFill>
+            <a:srgbClr val="16203F"/>
+          </a:solidFill>
+          <a:ln w="9525">
+            <a:solidFill>
+              <a:srgbClr val="2A3A6B"/>
+            </a:solidFill>
+            <a:prstDash val="solid"/>
+          </a:ln>
+        </p:spPr>
+      </p:sp>
+      <p:sp>
+        <p:nvSpPr>
+          <p:cNvPr id="6" name="Shape 4"/>
+          <p:cNvSpPr/>
+          <p:nvPr/>
+        </p:nvSpPr>
+        <p:spPr>
+          <a:xfrm>
+            <a:off x="868680" y="1965960"/>
+            <a:ext cx="502920" cy="502920"/>
+          </a:xfrm>
+          <a:prstGeom prst="ellipse">
+            <a:avLst/>
+          </a:prstGeom>
+          <a:solidFill>
+            <a:srgbClr val="0E3A44"/>
+          </a:solidFill>
+          <a:ln w="12700">
+            <a:solidFill>
+              <a:srgbClr val="0E3A44"/>
+            </a:solidFill>
+            <a:prstDash val="solid"/>
+          </a:ln>
+        </p:spPr>
+      </p:sp>
+      <p:pic>
+        <p:nvPicPr>
+          <p:cNvPr id="7" name="Image 0" descr="preencoded.png">    </p:cNvPr>
+          <p:cNvPicPr>
+            <a:picLocks noChangeAspect="1"/>
+          </p:cNvPicPr>
+          <p:nvPr/>
+        </p:nvPicPr>
+        <p:blipFill>
+          <a:blip r:embed="rId1"/>
+          <a:stretch>
+            <a:fillRect/>
+          </a:stretch>
+        </p:blipFill>
+        <p:spPr>
+          <a:xfrm>
+            <a:off x="1004468" y="2101748"/>
+            <a:ext cx="231343" cy="231343"/>
+          </a:xfrm>
+          <a:prstGeom prst="rect">
+            <a:avLst/>
+          </a:prstGeom>
+        </p:spPr>
+      </p:pic>
+      <p:sp>
+        <p:nvSpPr>
+          <p:cNvPr id="8" name="Text 5"/>
+          <p:cNvSpPr/>
+          <p:nvPr/>
+        </p:nvSpPr>
+        <p:spPr>
+          <a:xfrm>
+            <a:off x="1508760" y="1965960"/>
+            <a:ext cx="2743200" cy="502920"/>
+          </a:xfrm>
+          <a:prstGeom prst="rect">
+            <a:avLst/>
+          </a:prstGeom>
+          <a:noFill/>
+          <a:ln/>
+        </p:spPr>
+        <p:txBody>
+          <a:bodyPr wrap="square" lIns="0" tIns="0" rIns="0" bIns="0" rtlCol="0" anchor="ctr"/>
+          <a:lstStyle/>
+          <a:p>
+            <a:pPr indent="0" marL="0">
+              <a:buNone/>
+            </a:pPr>
+            <a:r>
+              <a:rPr lang="en-US" sz="1500" b="1" dirty="0">
+                <a:solidFill>
+                  <a:srgbClr val="F4F7FF"/>
+                </a:solidFill>
+                <a:latin typeface="Arial" pitchFamily="34" charset="0"/>
+                <a:ea typeface="Arial" pitchFamily="34" charset="-122"/>
+                <a:cs typeface="Arial" pitchFamily="34" charset="-120"/>
+              </a:rPr>
+              <a:t>Build ottimizzata</a:t>
+            </a:r>
+            <a:endParaRPr lang="en-US" sz="1500" dirty="0"/>
+          </a:p>
+        </p:txBody>
+      </p:sp>
+      <p:sp>
+        <p:nvSpPr>
+          <p:cNvPr id="9" name="Text 6"/>
+          <p:cNvSpPr/>
+          <p:nvPr/>
+        </p:nvSpPr>
+        <p:spPr>
+          <a:xfrm>
+            <a:off x="868680" y="2578608"/>
+            <a:ext cx="3337560" cy="1234440"/>
+          </a:xfrm>
+          <a:prstGeom prst="rect">
+            <a:avLst/>
+          </a:prstGeom>
+          <a:noFill/>
+          <a:ln/>
+        </p:spPr>
+        <p:txBody>
+          <a:bodyPr wrap="square" lIns="0" tIns="0" rIns="0" bIns="0" rtlCol="0" anchor="t"/>
+          <a:lstStyle/>
+          <a:p>
+            <a:pPr indent="0" marL="0">
+              <a:lnSpc>
+                <a:spcPct val="118000"/>
+              </a:lnSpc>
+              <a:buNone/>
+            </a:pPr>
+            <a:r>
+              <a:rPr lang="en-US" sz="1150" dirty="0">
+                <a:solidFill>
+                  <a:srgbClr val="AEBDE0"/>
+                </a:solidFill>
+                <a:latin typeface="Arial" pitchFamily="34" charset="0"/>
+                <a:ea typeface="Arial" pitchFamily="34" charset="-122"/>
+                <a:cs typeface="Arial" pitchFamily="34" charset="-120"/>
+              </a:rPr>
+              <a:t>Chiedi a Claude la compilazione più adatta all'uso: la versione di test si genera molto più in fretta di quella per lo store.</a:t>
+            </a:r>
+            <a:endParaRPr lang="en-US" sz="1150" dirty="0"/>
+          </a:p>
+        </p:txBody>
+      </p:sp>
+      <p:sp>
+        <p:nvSpPr>
+          <p:cNvPr id="10" name="Shape 7"/>
+          <p:cNvSpPr/>
+          <p:nvPr/>
+        </p:nvSpPr>
+        <p:spPr>
+          <a:xfrm>
+            <a:off x="4709160" y="1737360"/>
+            <a:ext cx="3794760" cy="2194560"/>
+          </a:xfrm>
+          <a:prstGeom prst="roundRect">
+            <a:avLst>
+              <a:gd name="adj" fmla="val 3333"/>
+            </a:avLst>
+          </a:prstGeom>
+          <a:solidFill>
+            <a:srgbClr val="16203F"/>
+          </a:solidFill>
+          <a:ln w="9525">
+            <a:solidFill>
+              <a:srgbClr val="2A3A6B"/>
+            </a:solidFill>
+            <a:prstDash val="solid"/>
+          </a:ln>
+        </p:spPr>
+      </p:sp>
+      <p:sp>
+        <p:nvSpPr>
+          <p:cNvPr id="11" name="Shape 8"/>
+          <p:cNvSpPr/>
+          <p:nvPr/>
+        </p:nvSpPr>
+        <p:spPr>
+          <a:xfrm>
+            <a:off x="4937760" y="1965960"/>
+            <a:ext cx="502920" cy="502920"/>
+          </a:xfrm>
+          <a:prstGeom prst="ellipse">
+            <a:avLst/>
+          </a:prstGeom>
+          <a:solidFill>
+            <a:srgbClr val="0E3A44"/>
+          </a:solidFill>
+          <a:ln w="12700">
+            <a:solidFill>
+              <a:srgbClr val="0E3A44"/>
+            </a:solidFill>
+            <a:prstDash val="solid"/>
+          </a:ln>
+        </p:spPr>
+      </p:sp>
+      <p:pic>
+        <p:nvPicPr>
+          <p:cNvPr id="12" name="Image 1" descr="preencoded.png">    </p:cNvPr>
+          <p:cNvPicPr>
+            <a:picLocks noChangeAspect="1"/>
+          </p:cNvPicPr>
+          <p:nvPr/>
+        </p:nvPicPr>
+        <p:blipFill>
+          <a:blip r:embed="rId2"/>
+          <a:stretch>
+            <a:fillRect/>
+          </a:stretch>
+        </p:blipFill>
+        <p:spPr>
+          <a:xfrm>
+            <a:off x="5073548" y="2101748"/>
+            <a:ext cx="231343" cy="231343"/>
+          </a:xfrm>
+          <a:prstGeom prst="rect">
+            <a:avLst/>
+          </a:prstGeom>
+        </p:spPr>
+      </p:pic>
+      <p:sp>
+        <p:nvSpPr>
+          <p:cNvPr id="13" name="Text 9"/>
+          <p:cNvSpPr/>
+          <p:nvPr/>
+        </p:nvSpPr>
+        <p:spPr>
+          <a:xfrm>
+            <a:off x="5577840" y="1965960"/>
+            <a:ext cx="2743200" cy="502920"/>
+          </a:xfrm>
+          <a:prstGeom prst="rect">
+            <a:avLst/>
+          </a:prstGeom>
+          <a:noFill/>
+          <a:ln/>
+        </p:spPr>
+        <p:txBody>
+          <a:bodyPr wrap="square" lIns="0" tIns="0" rIns="0" bIns="0" rtlCol="0" anchor="ctr"/>
+          <a:lstStyle/>
+          <a:p>
+            <a:pPr indent="0" marL="0">
+              <a:buNone/>
+            </a:pPr>
+            <a:r>
+              <a:rPr lang="en-US" sz="1500" b="1" dirty="0">
+                <a:solidFill>
+                  <a:srgbClr val="F4F7FF"/>
+                </a:solidFill>
+                <a:latin typeface="Arial" pitchFamily="34" charset="0"/>
+                <a:ea typeface="Arial" pitchFamily="34" charset="-122"/>
+                <a:cs typeface="Arial" pitchFamily="34" charset="-120"/>
+              </a:rPr>
+              <a:t>Solo quando serve</a:t>
+            </a:r>
+            <a:endParaRPr lang="en-US" sz="1500" dirty="0"/>
+          </a:p>
+        </p:txBody>
+      </p:sp>
+      <p:sp>
+        <p:nvSpPr>
+          <p:cNvPr id="14" name="Text 10"/>
+          <p:cNvSpPr/>
+          <p:nvPr/>
+        </p:nvSpPr>
+        <p:spPr>
+          <a:xfrm>
+            <a:off x="4937760" y="2578608"/>
+            <a:ext cx="3337560" cy="1234440"/>
+          </a:xfrm>
+          <a:prstGeom prst="rect">
+            <a:avLst/>
+          </a:prstGeom>
+          <a:noFill/>
+          <a:ln/>
+        </p:spPr>
+        <p:txBody>
+          <a:bodyPr wrap="square" lIns="0" tIns="0" rIns="0" bIns="0" rtlCol="0" anchor="t"/>
+          <a:lstStyle/>
+          <a:p>
+            <a:pPr indent="0" marL="0">
+              <a:lnSpc>
+                <a:spcPct val="118000"/>
+              </a:lnSpc>
+              <a:buNone/>
+            </a:pPr>
+            <a:r>
+              <a:rPr lang="en-US" sz="1150" dirty="0">
+                <a:solidFill>
+                  <a:srgbClr val="AEBDE0"/>
+                </a:solidFill>
+                <a:latin typeface="Arial" pitchFamily="34" charset="0"/>
+                <a:ea typeface="Arial" pitchFamily="34" charset="-122"/>
+                <a:cs typeface="Arial" pitchFamily="34" charset="-120"/>
+              </a:rPr>
+              <a:t>Accorpa le modifiche e compila una volta sola. Ricompilare per ogni micro-cambiamento è tempo buttato.</a:t>
+            </a:r>
+            <a:endParaRPr lang="en-US" sz="1150" dirty="0"/>
+          </a:p>
+        </p:txBody>
+      </p:sp>
+      <p:sp>
+        <p:nvSpPr>
+          <p:cNvPr id="15" name="Shape 11"/>
+          <p:cNvSpPr/>
+          <p:nvPr/>
+        </p:nvSpPr>
+        <p:spPr>
+          <a:xfrm>
+            <a:off x="640080" y="4160520"/>
+            <a:ext cx="7863840" cy="566928"/>
+          </a:xfrm>
+          <a:prstGeom prst="roundRect">
+            <a:avLst>
+              <a:gd name="adj" fmla="val 9677"/>
+            </a:avLst>
+          </a:prstGeom>
+          <a:solidFill>
+            <a:srgbClr val="0E3A44"/>
+          </a:solidFill>
+          <a:ln w="6350">
+            <a:solidFill>
+              <a:srgbClr val="2BD9E5"/>
+            </a:solidFill>
+            <a:prstDash val="solid"/>
+          </a:ln>
+        </p:spPr>
+      </p:sp>
+      <p:sp>
+        <p:nvSpPr>
+          <p:cNvPr id="16" name="Text 12"/>
+          <p:cNvSpPr/>
+          <p:nvPr/>
+        </p:nvSpPr>
+        <p:spPr>
+          <a:xfrm>
+            <a:off x="822960" y="4160520"/>
+            <a:ext cx="7498080" cy="566928"/>
+          </a:xfrm>
+          <a:prstGeom prst="rect">
+            <a:avLst/>
+          </a:prstGeom>
+          <a:noFill/>
+          <a:ln/>
+        </p:spPr>
+        <p:txBody>
+          <a:bodyPr wrap="square" lIns="0" tIns="0" rIns="0" bIns="0" rtlCol="0" anchor="ctr"/>
+          <a:lstStyle/>
+          <a:p>
+            <a:pPr algn="ctr" indent="0" marL="0">
+              <a:buNone/>
+            </a:pPr>
+            <a:r>
+              <a:rPr lang="en-US" sz="1250" dirty="0">
+                <a:solidFill>
+                  <a:srgbClr val="F4F7FF"/>
+                </a:solidFill>
+                <a:latin typeface="Arial" pitchFamily="34" charset="0"/>
+                <a:ea typeface="Arial" pitchFamily="34" charset="-122"/>
+                <a:cs typeface="Arial" pitchFamily="34" charset="-120"/>
+              </a:rPr>
+              <a:t>Su un computer normale una build può prendere 10 minuti e rallentare tutto.</a:t>
+            </a:r>
+            <a:endParaRPr lang="en-US" sz="1250" dirty="0"/>
+          </a:p>
+        </p:txBody>
+      </p:sp>
+    </p:spTree>
+  </p:cSld>
+  <p:clrMapOvr>
+    <a:masterClrMapping/>
+  </p:clrMapOvr>
+</p:sld>
+</file>
+
+<file path=ppt/slides/slide26.xml><?xml version="1.0" encoding="utf-8"?>
+<p:sld xmlns:a="http://schemas.openxmlformats.org/drawingml/2006/main" xmlns:r="http://schemas.openxmlformats.org/officeDocument/2006/relationships" xmlns:p="http://schemas.openxmlformats.org/presentationml/2006/main">
+  <p:cSld name="Slide 26">
+    <p:bg>
+      <p:bgPr>
+        <a:solidFill>
+          <a:srgbClr val="0B1226"/>
+        </a:solidFill>
+      </p:bgPr>
+    </p:bg>
+    <p:spTree>
+      <p:nvGrpSpPr>
+        <p:cNvPr id="1" name=""/>
+        <p:cNvGrpSpPr/>
+        <p:nvPr/>
+      </p:nvGrpSpPr>
+      <p:grpSpPr>
+        <a:xfrm>
+          <a:off x="0" y="0"/>
+          <a:ext cx="0" cy="0"/>
+          <a:chOff x="0" y="0"/>
+          <a:chExt cx="0" cy="0"/>
+        </a:xfrm>
+      </p:grpSpPr>
+      <p:sp>
+        <p:nvSpPr>
+          <p:cNvPr id="2" name="Text 0"/>
+          <p:cNvSpPr/>
+          <p:nvPr/>
+        </p:nvSpPr>
+        <p:spPr>
+          <a:xfrm>
+            <a:off x="640080" y="365760"/>
+            <a:ext cx="8229600" cy="274320"/>
+          </a:xfrm>
+          <a:prstGeom prst="rect">
+            <a:avLst/>
+          </a:prstGeom>
+          <a:noFill/>
+          <a:ln/>
+        </p:spPr>
+        <p:txBody>
+          <a:bodyPr wrap="square" lIns="0" tIns="0" rIns="0" bIns="0" rtlCol="0" anchor="ctr"/>
+          <a:lstStyle/>
+          <a:p>
+            <a:pPr indent="0" marL="0">
+              <a:buNone/>
+            </a:pPr>
+            <a:r>
+              <a:rPr lang="en-US" sz="1100" b="1" spc="200" kern="0" dirty="0">
+                <a:solidFill>
+                  <a:srgbClr val="2BD9E5"/>
+                </a:solidFill>
+                <a:latin typeface="Arial" pitchFamily="34" charset="0"/>
+                <a:ea typeface="Arial" pitchFamily="34" charset="-122"/>
+                <a:cs typeface="Arial" pitchFamily="34" charset="-120"/>
+              </a:rPr>
+              <a:t>DA TENERE A MENTE · 3 · LE REGOLE DELLO STORE</a:t>
+            </a:r>
+            <a:endParaRPr lang="en-US" sz="1100" dirty="0"/>
+          </a:p>
+        </p:txBody>
+      </p:sp>
+      <p:sp>
+        <p:nvSpPr>
+          <p:cNvPr id="3" name="Text 1"/>
+          <p:cNvSpPr/>
+          <p:nvPr/>
+        </p:nvSpPr>
+        <p:spPr>
+          <a:xfrm>
+            <a:off x="640080" y="640080"/>
+            <a:ext cx="7863840" cy="566928"/>
+          </a:xfrm>
+          <a:prstGeom prst="rect">
+            <a:avLst/>
+          </a:prstGeom>
+          <a:noFill/>
+          <a:ln/>
+        </p:spPr>
+        <p:txBody>
+          <a:bodyPr wrap="square" lIns="0" tIns="0" rIns="0" bIns="0" rtlCol="0" anchor="ctr"/>
+          <a:lstStyle/>
+          <a:p>
+            <a:pPr indent="0" marL="0">
+              <a:buNone/>
+            </a:pPr>
+            <a:r>
+              <a:rPr lang="en-US" sz="3000" dirty="0">
+                <a:solidFill>
+                  <a:srgbClr val="F4F7FF"/>
+                </a:solidFill>
+                <a:latin typeface="Arial Black" pitchFamily="34" charset="0"/>
+                <a:ea typeface="Arial Black" pitchFamily="34" charset="-122"/>
+                <a:cs typeface="Arial Black" pitchFamily="34" charset="-120"/>
+              </a:rPr>
+              <a:t>Leggi le regole dello store</a:t>
+            </a:r>
+            <a:endParaRPr lang="en-US" sz="3000" dirty="0"/>
+          </a:p>
+        </p:txBody>
+      </p:sp>
+      <p:sp>
+        <p:nvSpPr>
+          <p:cNvPr id="4" name="Text 2"/>
+          <p:cNvSpPr/>
+          <p:nvPr/>
+        </p:nvSpPr>
+        <p:spPr>
+          <a:xfrm>
+            <a:off x="658368" y="1188720"/>
+            <a:ext cx="7772400" cy="310896"/>
+          </a:xfrm>
+          <a:prstGeom prst="rect">
+            <a:avLst/>
+          </a:prstGeom>
+          <a:noFill/>
+          <a:ln/>
+        </p:spPr>
+        <p:txBody>
+          <a:bodyPr wrap="square" lIns="0" tIns="0" rIns="0" bIns="0" rtlCol="0" anchor="ctr"/>
+          <a:lstStyle/>
+          <a:p>
+            <a:pPr indent="0" marL="0">
+              <a:buNone/>
+            </a:pPr>
+            <a:r>
+              <a:rPr lang="en-US" sz="1350" i="1" dirty="0">
+                <a:solidFill>
+                  <a:srgbClr val="AEBDE0"/>
+                </a:solidFill>
+                <a:latin typeface="Arial" pitchFamily="34" charset="0"/>
+                <a:ea typeface="Arial" pitchFamily="34" charset="-122"/>
+                <a:cs typeface="Arial" pitchFamily="34" charset="-120"/>
+              </a:rPr>
+              <a:t>Gli store hanno regole che cambiano nel tempo — e non riguardano solo il codice.</a:t>
+            </a:r>
+            <a:endParaRPr lang="en-US" sz="1350" dirty="0"/>
+          </a:p>
+        </p:txBody>
+      </p:sp>
+      <p:sp>
+        <p:nvSpPr>
+          <p:cNvPr id="5" name="Shape 3"/>
+          <p:cNvSpPr/>
+          <p:nvPr/>
+        </p:nvSpPr>
+        <p:spPr>
+          <a:xfrm>
+            <a:off x="640080" y="1737360"/>
+            <a:ext cx="3794760" cy="2194560"/>
+          </a:xfrm>
+          <a:prstGeom prst="roundRect">
+            <a:avLst>
+              <a:gd name="adj" fmla="val 3333"/>
+            </a:avLst>
+          </a:prstGeom>
+          <a:solidFill>
+            <a:srgbClr val="16203F"/>
+          </a:solidFill>
+          <a:ln w="9525">
+            <a:solidFill>
+              <a:srgbClr val="2A3A6B"/>
+            </a:solidFill>
+            <a:prstDash val="solid"/>
+          </a:ln>
+        </p:spPr>
+      </p:sp>
+      <p:sp>
+        <p:nvSpPr>
+          <p:cNvPr id="6" name="Shape 4"/>
+          <p:cNvSpPr/>
+          <p:nvPr/>
+        </p:nvSpPr>
+        <p:spPr>
+          <a:xfrm>
+            <a:off x="868680" y="1965960"/>
+            <a:ext cx="502920" cy="502920"/>
+          </a:xfrm>
+          <a:prstGeom prst="ellipse">
+            <a:avLst/>
+          </a:prstGeom>
+          <a:solidFill>
+            <a:srgbClr val="0E3A44"/>
+          </a:solidFill>
+          <a:ln w="12700">
+            <a:solidFill>
+              <a:srgbClr val="0E3A44"/>
+            </a:solidFill>
+            <a:prstDash val="solid"/>
+          </a:ln>
+        </p:spPr>
+      </p:sp>
+      <p:pic>
+        <p:nvPicPr>
+          <p:cNvPr id="7" name="Image 0" descr="preencoded.png">    </p:cNvPr>
+          <p:cNvPicPr>
+            <a:picLocks noChangeAspect="1"/>
+          </p:cNvPicPr>
+          <p:nvPr/>
+        </p:nvPicPr>
+        <p:blipFill>
+          <a:blip r:embed="rId1"/>
+          <a:stretch>
+            <a:fillRect/>
+          </a:stretch>
+        </p:blipFill>
+        <p:spPr>
+          <a:xfrm>
+            <a:off x="1004468" y="2101748"/>
+            <a:ext cx="231343" cy="231343"/>
+          </a:xfrm>
+          <a:prstGeom prst="rect">
+            <a:avLst/>
+          </a:prstGeom>
+        </p:spPr>
+      </p:pic>
+      <p:sp>
+        <p:nvSpPr>
+          <p:cNvPr id="8" name="Text 5"/>
+          <p:cNvSpPr/>
+          <p:nvPr/>
+        </p:nvSpPr>
+        <p:spPr>
+          <a:xfrm>
+            <a:off x="1508760" y="1965960"/>
+            <a:ext cx="2743200" cy="502920"/>
+          </a:xfrm>
+          <a:prstGeom prst="rect">
+            <a:avLst/>
+          </a:prstGeom>
+          <a:noFill/>
+          <a:ln/>
+        </p:spPr>
+        <p:txBody>
+          <a:bodyPr wrap="square" lIns="0" tIns="0" rIns="0" bIns="0" rtlCol="0" anchor="ctr"/>
+          <a:lstStyle/>
+          <a:p>
+            <a:pPr indent="0" marL="0">
+              <a:buNone/>
+            </a:pPr>
+            <a:r>
+              <a:rPr lang="en-US" sz="1500" b="1" dirty="0">
+                <a:solidFill>
+                  <a:srgbClr val="F4F7FF"/>
+                </a:solidFill>
+                <a:latin typeface="Arial" pitchFamily="34" charset="0"/>
+                <a:ea typeface="Arial" pitchFamily="34" charset="-122"/>
+                <a:cs typeface="Arial" pitchFamily="34" charset="-120"/>
+              </a:rPr>
+              <a:t>Falle leggere a Claude</a:t>
+            </a:r>
+            <a:endParaRPr lang="en-US" sz="1500" dirty="0"/>
+          </a:p>
+        </p:txBody>
+      </p:sp>
+      <p:sp>
+        <p:nvSpPr>
+          <p:cNvPr id="9" name="Text 6"/>
+          <p:cNvSpPr/>
+          <p:nvPr/>
+        </p:nvSpPr>
+        <p:spPr>
+          <a:xfrm>
+            <a:off x="868680" y="2578608"/>
+            <a:ext cx="3337560" cy="1234440"/>
+          </a:xfrm>
+          <a:prstGeom prst="rect">
+            <a:avLst/>
+          </a:prstGeom>
+          <a:noFill/>
+          <a:ln/>
+        </p:spPr>
+        <p:txBody>
+          <a:bodyPr wrap="square" lIns="0" tIns="0" rIns="0" bIns="0" rtlCol="0" anchor="t"/>
+          <a:lstStyle/>
+          <a:p>
+            <a:pPr indent="0" marL="0">
+              <a:lnSpc>
+                <a:spcPct val="118000"/>
+              </a:lnSpc>
+              <a:buNone/>
+            </a:pPr>
+            <a:r>
+              <a:rPr lang="en-US" sz="1150" dirty="0">
+                <a:solidFill>
+                  <a:srgbClr val="AEBDE0"/>
+                </a:solidFill>
+                <a:latin typeface="Arial" pitchFamily="34" charset="0"/>
+                <a:ea typeface="Arial" pitchFamily="34" charset="-122"/>
+                <a:cs typeface="Arial" pitchFamily="34" charset="-120"/>
+              </a:rPr>
+              <a:t>Requisiti su come scrivere il codice, come compilare, su icona, testi, permessi e privacy: falle leggere bene prima di iniziare.</a:t>
+            </a:r>
+            <a:endParaRPr lang="en-US" sz="1150" dirty="0"/>
+          </a:p>
+        </p:txBody>
+      </p:sp>
+      <p:sp>
+        <p:nvSpPr>
+          <p:cNvPr id="10" name="Shape 7"/>
+          <p:cNvSpPr/>
+          <p:nvPr/>
+        </p:nvSpPr>
+        <p:spPr>
+          <a:xfrm>
+            <a:off x="4709160" y="1737360"/>
+            <a:ext cx="3794760" cy="2194560"/>
+          </a:xfrm>
+          <a:prstGeom prst="roundRect">
+            <a:avLst>
+              <a:gd name="adj" fmla="val 3333"/>
+            </a:avLst>
+          </a:prstGeom>
+          <a:solidFill>
+            <a:srgbClr val="16203F"/>
+          </a:solidFill>
+          <a:ln w="9525">
+            <a:solidFill>
+              <a:srgbClr val="2A3A6B"/>
+            </a:solidFill>
+            <a:prstDash val="solid"/>
+          </a:ln>
+        </p:spPr>
+      </p:sp>
+      <p:sp>
+        <p:nvSpPr>
+          <p:cNvPr id="11" name="Shape 8"/>
+          <p:cNvSpPr/>
+          <p:nvPr/>
+        </p:nvSpPr>
+        <p:spPr>
+          <a:xfrm>
+            <a:off x="4937760" y="1965960"/>
+            <a:ext cx="502920" cy="502920"/>
+          </a:xfrm>
+          <a:prstGeom prst="ellipse">
+            <a:avLst/>
+          </a:prstGeom>
+          <a:solidFill>
+            <a:srgbClr val="0E3A44"/>
+          </a:solidFill>
+          <a:ln w="12700">
+            <a:solidFill>
+              <a:srgbClr val="0E3A44"/>
+            </a:solidFill>
+            <a:prstDash val="solid"/>
+          </a:ln>
+        </p:spPr>
+      </p:sp>
+      <p:pic>
+        <p:nvPicPr>
+          <p:cNvPr id="12" name="Image 1" descr="preencoded.png">    </p:cNvPr>
+          <p:cNvPicPr>
+            <a:picLocks noChangeAspect="1"/>
+          </p:cNvPicPr>
+          <p:nvPr/>
+        </p:nvPicPr>
+        <p:blipFill>
+          <a:blip r:embed="rId2"/>
+          <a:stretch>
+            <a:fillRect/>
+          </a:stretch>
+        </p:blipFill>
+        <p:spPr>
+          <a:xfrm>
+            <a:off x="5073548" y="2101748"/>
+            <a:ext cx="231343" cy="231343"/>
+          </a:xfrm>
+          <a:prstGeom prst="rect">
+            <a:avLst/>
+          </a:prstGeom>
+        </p:spPr>
+      </p:pic>
+      <p:sp>
+        <p:nvSpPr>
+          <p:cNvPr id="13" name="Text 9"/>
+          <p:cNvSpPr/>
+          <p:nvPr/>
+        </p:nvSpPr>
+        <p:spPr>
+          <a:xfrm>
+            <a:off x="5577840" y="1965960"/>
+            <a:ext cx="2743200" cy="502920"/>
+          </a:xfrm>
+          <a:prstGeom prst="rect">
+            <a:avLst/>
+          </a:prstGeom>
+          <a:noFill/>
+          <a:ln/>
+        </p:spPr>
+        <p:txBody>
+          <a:bodyPr wrap="square" lIns="0" tIns="0" rIns="0" bIns="0" rtlCol="0" anchor="ctr"/>
+          <a:lstStyle/>
+          <a:p>
+            <a:pPr indent="0" marL="0">
+              <a:buNone/>
+            </a:pPr>
+            <a:r>
+              <a:rPr lang="en-US" sz="1500" b="1" dirty="0">
+                <a:solidFill>
+                  <a:srgbClr val="F4F7FF"/>
+                </a:solidFill>
+                <a:latin typeface="Arial" pitchFamily="34" charset="0"/>
+                <a:ea typeface="Arial" pitchFamily="34" charset="-122"/>
+                <a:cs typeface="Arial" pitchFamily="34" charset="-120"/>
+              </a:rPr>
+              <a:t>Un dettaglio può bloccarti</a:t>
+            </a:r>
+            <a:endParaRPr lang="en-US" sz="1500" dirty="0"/>
+          </a:p>
+        </p:txBody>
+      </p:sp>
+      <p:sp>
+        <p:nvSpPr>
+          <p:cNvPr id="14" name="Text 10"/>
+          <p:cNvSpPr/>
+          <p:nvPr/>
+        </p:nvSpPr>
+        <p:spPr>
+          <a:xfrm>
+            <a:off x="4937760" y="2578608"/>
+            <a:ext cx="3337560" cy="1234440"/>
+          </a:xfrm>
+          <a:prstGeom prst="rect">
+            <a:avLst/>
+          </a:prstGeom>
+          <a:noFill/>
+          <a:ln/>
+        </p:spPr>
+        <p:txBody>
+          <a:bodyPr wrap="square" lIns="0" tIns="0" rIns="0" bIns="0" rtlCol="0" anchor="t"/>
+          <a:lstStyle/>
+          <a:p>
+            <a:pPr indent="0" marL="0">
+              <a:lnSpc>
+                <a:spcPct val="118000"/>
+              </a:lnSpc>
+              <a:buNone/>
+            </a:pPr>
+            <a:r>
+              <a:rPr lang="en-US" sz="1150" dirty="0">
+                <a:solidFill>
+                  <a:srgbClr val="AEBDE0"/>
+                </a:solidFill>
+                <a:latin typeface="Arial" pitchFamily="34" charset="0"/>
+                <a:ea typeface="Arial" pitchFamily="34" charset="-122"/>
+                <a:cs typeface="Arial" pitchFamily="34" charset="-120"/>
+              </a:rPr>
+              <a:t>A volte basta un'icona o un testo fuori regola per dover ricompilare e ricaricare tutto, anche col codice perfetto.</a:t>
+            </a:r>
+            <a:endParaRPr lang="en-US" sz="1150" dirty="0"/>
+          </a:p>
+        </p:txBody>
+      </p:sp>
+      <p:sp>
+        <p:nvSpPr>
+          <p:cNvPr id="15" name="Shape 11"/>
+          <p:cNvSpPr/>
+          <p:nvPr/>
+        </p:nvSpPr>
+        <p:spPr>
+          <a:xfrm>
+            <a:off x="640080" y="4160520"/>
+            <a:ext cx="7863840" cy="566928"/>
+          </a:xfrm>
+          <a:prstGeom prst="roundRect">
+            <a:avLst>
+              <a:gd name="adj" fmla="val 9677"/>
+            </a:avLst>
+          </a:prstGeom>
+          <a:solidFill>
+            <a:srgbClr val="0E3A44"/>
+          </a:solidFill>
+          <a:ln w="6350">
+            <a:solidFill>
+              <a:srgbClr val="2BD9E5"/>
+            </a:solidFill>
+            <a:prstDash val="solid"/>
+          </a:ln>
+        </p:spPr>
+      </p:sp>
+      <p:sp>
+        <p:nvSpPr>
+          <p:cNvPr id="16" name="Text 12"/>
+          <p:cNvSpPr/>
+          <p:nvPr/>
+        </p:nvSpPr>
+        <p:spPr>
+          <a:xfrm>
+            <a:off x="822960" y="4160520"/>
+            <a:ext cx="7498080" cy="566928"/>
+          </a:xfrm>
+          <a:prstGeom prst="rect">
+            <a:avLst/>
+          </a:prstGeom>
+          <a:noFill/>
+          <a:ln/>
+        </p:spPr>
+        <p:txBody>
+          <a:bodyPr wrap="square" lIns="0" tIns="0" rIns="0" bIns="0" rtlCol="0" anchor="ctr"/>
+          <a:lstStyle/>
+          <a:p>
+            <a:pPr algn="ctr" indent="0" marL="0">
+              <a:buNone/>
+            </a:pPr>
+            <a:r>
+              <a:rPr lang="en-US" sz="1250" dirty="0">
+                <a:solidFill>
+                  <a:srgbClr val="F4F7FF"/>
+                </a:solidFill>
+                <a:latin typeface="Arial" pitchFamily="34" charset="0"/>
+                <a:ea typeface="Arial" pitchFamily="34" charset="-122"/>
+                <a:cs typeface="Arial" pitchFamily="34" charset="-120"/>
+              </a:rPr>
+              <a:t>Le regole di pubblicazione cambiano: ricontrollale a ogni release importante.</a:t>
+            </a:r>
+            <a:endParaRPr lang="en-US" sz="1250" dirty="0"/>
+          </a:p>
+        </p:txBody>
+      </p:sp>
+    </p:spTree>
+  </p:cSld>
+  <p:clrMapOvr>
+    <a:masterClrMapping/>
+  </p:clrMapOvr>
+</p:sld>
+</file>
+
 <file path=ppt/slides/slide3.xml><?xml version="1.0" encoding="utf-8"?>
 <p:sld xmlns:a="http://schemas.openxmlformats.org/drawingml/2006/main" xmlns:r="http://schemas.openxmlformats.org/officeDocument/2006/relationships" xmlns:p="http://schemas.openxmlformats.org/presentationml/2006/main">
   <p:cSld name="Slide 3">

</xml_diff>

<commit_message>
feat(video): copertina con smartphone stilizzato al posto del motivo Beyblade
Co-Authored-By: Claude Fable 5 <noreply@anthropic.com>
</commit_message>
<xml_diff>
--- a/video/slide-video-ai.pptx
+++ b/video/slide-video-ai.pptx
@@ -3108,8 +3108,89 @@
         </p:nvSpPr>
         <p:spPr>
           <a:xfrm>
-            <a:off x="5852160" y="822960"/>
-            <a:ext cx="3108960" cy="3108960"/>
+            <a:off x="6629400" y="868680"/>
+            <a:ext cx="1783080" cy="2880360"/>
+          </a:xfrm>
+          <a:prstGeom prst="roundRect">
+            <a:avLst>
+              <a:gd name="adj" fmla="val 11282"/>
+            </a:avLst>
+          </a:prstGeom>
+          <a:solidFill>
+            <a:srgbClr val="0B1226">
+              <a:alpha val="0"/>
+            </a:srgbClr>
+          </a:solidFill>
+          <a:ln w="25400">
+            <a:solidFill>
+              <a:srgbClr val="2BD9E5"/>
+            </a:solidFill>
+            <a:prstDash val="solid"/>
+          </a:ln>
+        </p:spPr>
+      </p:sp>
+      <p:sp>
+        <p:nvSpPr>
+          <p:cNvPr id="3" name="Shape 1"/>
+          <p:cNvSpPr/>
+          <p:nvPr/>
+        </p:nvSpPr>
+        <p:spPr>
+          <a:xfrm>
+            <a:off x="7269480" y="1161288"/>
+            <a:ext cx="502920" cy="0"/>
+          </a:xfrm>
+          <a:prstGeom prst="line">
+            <a:avLst/>
+          </a:prstGeom>
+          <a:noFill/>
+          <a:ln w="25400">
+            <a:solidFill>
+              <a:srgbClr val="2BD9E5"/>
+            </a:solidFill>
+            <a:prstDash val="solid"/>
+          </a:ln>
+        </p:spPr>
+      </p:sp>
+      <p:sp>
+        <p:nvSpPr>
+          <p:cNvPr id="4" name="Shape 2"/>
+          <p:cNvSpPr/>
+          <p:nvPr/>
+        </p:nvSpPr>
+        <p:spPr>
+          <a:xfrm>
+            <a:off x="6858000" y="1463040"/>
+            <a:ext cx="1325880" cy="146304"/>
+          </a:xfrm>
+          <a:prstGeom prst="rect">
+            <a:avLst/>
+          </a:prstGeom>
+          <a:solidFill>
+            <a:srgbClr val="2BD9E5">
+              <a:alpha val="35000"/>
+            </a:srgbClr>
+          </a:solidFill>
+          <a:ln w="12700">
+            <a:solidFill>
+              <a:srgbClr val="2BD9E5">
+                <a:alpha val="0"/>
+              </a:srgbClr>
+            </a:solidFill>
+            <a:prstDash val="solid"/>
+          </a:ln>
+        </p:spPr>
+      </p:sp>
+      <p:sp>
+        <p:nvSpPr>
+          <p:cNvPr id="5" name="Shape 3"/>
+          <p:cNvSpPr/>
+          <p:nvPr/>
+        </p:nvSpPr>
+        <p:spPr>
+          <a:xfrm>
+            <a:off x="7132320" y="1874520"/>
+            <a:ext cx="777240" cy="777240"/>
           </a:xfrm>
           <a:prstGeom prst="ellipse">
             <a:avLst/>
@@ -3121,8 +3202,55 @@
           </a:solidFill>
           <a:ln w="19050">
             <a:solidFill>
+              <a:srgbClr val="2BD9E5"/>
+            </a:solidFill>
+            <a:prstDash val="solid"/>
+          </a:ln>
+        </p:spPr>
+      </p:sp>
+      <p:sp>
+        <p:nvSpPr>
+          <p:cNvPr id="6" name="Shape 4"/>
+          <p:cNvSpPr/>
+          <p:nvPr/>
+        </p:nvSpPr>
+        <p:spPr>
+          <a:xfrm>
+            <a:off x="7360920" y="2103120"/>
+            <a:ext cx="320040" cy="320040"/>
+          </a:xfrm>
+          <a:prstGeom prst="ellipse">
+            <a:avLst/>
+          </a:prstGeom>
+          <a:solidFill>
+            <a:srgbClr val="2BD9E5"/>
+          </a:solidFill>
+          <a:ln/>
+        </p:spPr>
+      </p:sp>
+      <p:sp>
+        <p:nvSpPr>
+          <p:cNvPr id="7" name="Shape 5"/>
+          <p:cNvSpPr/>
+          <p:nvPr/>
+        </p:nvSpPr>
+        <p:spPr>
+          <a:xfrm>
+            <a:off x="6858000" y="2926080"/>
+            <a:ext cx="1325880" cy="137160"/>
+          </a:xfrm>
+          <a:prstGeom prst="rect">
+            <a:avLst/>
+          </a:prstGeom>
+          <a:solidFill>
+            <a:srgbClr val="2BD9E5">
+              <a:alpha val="35000"/>
+            </a:srgbClr>
+          </a:solidFill>
+          <a:ln w="12700">
+            <a:solidFill>
               <a:srgbClr val="2BD9E5">
-                <a:alpha val="30000"/>
+                <a:alpha val="0"/>
               </a:srgbClr>
             </a:solidFill>
             <a:prstDash val="solid"/>
@@ -3131,27 +3259,27 @@
       </p:sp>
       <p:sp>
         <p:nvSpPr>
-          <p:cNvPr id="3" name="Shape 1"/>
-          <p:cNvSpPr/>
-          <p:nvPr/>
-        </p:nvSpPr>
-        <p:spPr>
-          <a:xfrm>
-            <a:off x="6217920" y="1188720"/>
-            <a:ext cx="2377440" cy="2377440"/>
-          </a:xfrm>
-          <a:prstGeom prst="ellipse">
+          <p:cNvPr id="8" name="Shape 6"/>
+          <p:cNvSpPr/>
+          <p:nvPr/>
+        </p:nvSpPr>
+        <p:spPr>
+          <a:xfrm>
+            <a:off x="6858000" y="3200400"/>
+            <a:ext cx="868680" cy="137160"/>
+          </a:xfrm>
+          <a:prstGeom prst="rect">
             <a:avLst/>
           </a:prstGeom>
           <a:solidFill>
-            <a:srgbClr val="0B1226">
-              <a:alpha val="0"/>
+            <a:srgbClr val="2BD9E5">
+              <a:alpha val="22000"/>
             </a:srgbClr>
           </a:solidFill>
-          <a:ln w="19050">
+          <a:ln w="12700">
             <a:solidFill>
               <a:srgbClr val="2BD9E5">
-                <a:alpha val="55000"/>
+                <a:alpha val="0"/>
               </a:srgbClr>
             </a:solidFill>
             <a:prstDash val="solid"/>
@@ -3160,28 +3288,22 @@
       </p:sp>
       <p:sp>
         <p:nvSpPr>
-          <p:cNvPr id="4" name="Shape 2"/>
-          <p:cNvSpPr/>
-          <p:nvPr/>
-        </p:nvSpPr>
-        <p:spPr>
-          <a:xfrm>
-            <a:off x="6583680" y="1554480"/>
-            <a:ext cx="1645920" cy="1645920"/>
-          </a:xfrm>
-          <a:prstGeom prst="ellipse">
-            <a:avLst/>
-          </a:prstGeom>
-          <a:solidFill>
-            <a:srgbClr val="0B1226">
-              <a:alpha val="0"/>
-            </a:srgbClr>
-          </a:solidFill>
+          <p:cNvPr id="9" name="Shape 7"/>
+          <p:cNvSpPr/>
+          <p:nvPr/>
+        </p:nvSpPr>
+        <p:spPr>
+          <a:xfrm>
+            <a:off x="7269480" y="3547872"/>
+            <a:ext cx="502920" cy="0"/>
+          </a:xfrm>
+          <a:prstGeom prst="line">
+            <a:avLst/>
+          </a:prstGeom>
+          <a:noFill/>
           <a:ln w="25400">
             <a:solidFill>
-              <a:srgbClr val="2BD9E5">
-                <a:alpha val="85000"/>
-              </a:srgbClr>
+              <a:srgbClr val="2BD9E5"/>
             </a:solidFill>
             <a:prstDash val="solid"/>
           </a:ln>
@@ -3189,27 +3311,7 @@
       </p:sp>
       <p:sp>
         <p:nvSpPr>
-          <p:cNvPr id="5" name="Shape 3"/>
-          <p:cNvSpPr/>
-          <p:nvPr/>
-        </p:nvSpPr>
-        <p:spPr>
-          <a:xfrm>
-            <a:off x="7269480" y="2240280"/>
-            <a:ext cx="274320" cy="274320"/>
-          </a:xfrm>
-          <a:prstGeom prst="ellipse">
-            <a:avLst/>
-          </a:prstGeom>
-          <a:solidFill>
-            <a:srgbClr val="2BD9E5"/>
-          </a:solidFill>
-          <a:ln/>
-        </p:spPr>
-      </p:sp>
-      <p:sp>
-        <p:nvSpPr>
-          <p:cNvPr id="6" name="Text 4"/>
+          <p:cNvPr id="10" name="Text 8"/>
           <p:cNvSpPr/>
           <p:nvPr/>
         </p:nvSpPr>
@@ -3248,7 +3350,7 @@
       </p:sp>
       <p:sp>
         <p:nvSpPr>
-          <p:cNvPr id="7" name="Text 5"/>
+          <p:cNvPr id="11" name="Text 9"/>
           <p:cNvSpPr/>
           <p:nvPr/>
         </p:nvSpPr>
@@ -3310,7 +3412,7 @@
       </p:sp>
       <p:sp>
         <p:nvSpPr>
-          <p:cNvPr id="8" name="Text 6"/>
+          <p:cNvPr id="12" name="Text 10"/>
           <p:cNvSpPr/>
           <p:nvPr/>
         </p:nvSpPr>
@@ -3349,7 +3451,7 @@
       </p:sp>
       <p:sp>
         <p:nvSpPr>
-          <p:cNvPr id="9" name="Text 7"/>
+          <p:cNvPr id="13" name="Text 11"/>
           <p:cNvSpPr/>
           <p:nvPr/>
         </p:nvSpPr>
@@ -3388,7 +3490,7 @@
       </p:sp>
       <p:sp>
         <p:nvSpPr>
-          <p:cNvPr id="10" name="Text 8"/>
+          <p:cNvPr id="14" name="Text 12"/>
           <p:cNvSpPr/>
           <p:nvPr/>
         </p:nvSpPr>
@@ -3427,7 +3529,7 @@
       </p:sp>
       <p:sp>
         <p:nvSpPr>
-          <p:cNvPr id="11" name="Text 9"/>
+          <p:cNvPr id="15" name="Text 13"/>
           <p:cNvSpPr/>
           <p:nvPr/>
         </p:nvSpPr>
@@ -3466,7 +3568,7 @@
       </p:sp>
       <p:sp>
         <p:nvSpPr>
-          <p:cNvPr id="12" name="Text 10"/>
+          <p:cNvPr id="16" name="Text 14"/>
           <p:cNvSpPr/>
           <p:nvPr/>
         </p:nvSpPr>
@@ -3505,7 +3607,7 @@
       </p:sp>
       <p:sp>
         <p:nvSpPr>
-          <p:cNvPr id="13" name="Text 11"/>
+          <p:cNvPr id="17" name="Text 15"/>
           <p:cNvSpPr/>
           <p:nvPr/>
         </p:nvSpPr>
@@ -3544,7 +3646,7 @@
       </p:sp>
       <p:sp>
         <p:nvSpPr>
-          <p:cNvPr id="14" name="Text 12"/>
+          <p:cNvPr id="18" name="Text 16"/>
           <p:cNvSpPr/>
           <p:nvPr/>
         </p:nvSpPr>

</xml_diff>